<commit_message>
Rebuild the deck: designed HTML-rendered slides, new story arc, embedded visuals
Replaces the python-pptx bullet deck. Slides are designed in HTML/CSS and rendered
at 1920x1080, so screenshots and diagrams are embedded rather than left for the
presenter to place. 14 slides, speaker notes on all, plus a PDF for presenting.
</commit_message>
<xml_diff>
--- a/presentation/Diya-Internship-Report.pptx
+++ b/presentation/Diya-Internship-Report.pptx
@@ -15,6 +15,10 @@
     <p:sldId id="263" r:id="rId15"/>
     <p:sldId id="264" r:id="rId16"/>
     <p:sldId id="265" r:id="rId17"/>
+    <p:sldId id="266" r:id="rId18"/>
+    <p:sldId id="267" r:id="rId19"/>
+    <p:sldId id="268" r:id="rId20"/>
+    <p:sldId id="269" r:id="rId21"/>
   </p:sldIdLst>
   <p:sldSz cx="12191695" cy="6858000" type="screen4x3"/>
   <p:notesSz cx="6858000" cy="9144000"/>
@@ -511,38 +515,17 @@
           <a:lstStyle/>
           <a:p>
             <a:r>
-              <a:t>Open with one sentence that frames the whole thing:</a:t>
-            </a:r>
-          </a:p>
-          <a:p>
-            <a:r>
-              <a:t>"Diya is a meditation kiosk for a public museum setting - a visitor walks up with no</a:t>
-            </a:r>
-          </a:p>
-          <a:p>
-            <a:r>
-              <a:t>staff present, is identified, goes through a camera-guided session, gets a report,</a:t>
-            </a:r>
-          </a:p>
-          <a:p>
-            <a:r>
-              <a:t>and the machine resets itself. I built the software side of that."</a:t>
-            </a:r>
-          </a:p>
-          <a:p/>
-          <a:p>
-            <a:r>
-              <a:t>Then say what you'll cover: the problem, the architecture, the one design decision</a:t>
-            </a:r>
-          </a:p>
-          <a:p>
-            <a:r>
-              <a:t>that mattered most, the hard bugs, and where I left it.</a:t>
-            </a:r>
-          </a:p>
-          <a:p>
-            <a:r>
-              <a:t>Keep this slide to about 30 seconds.</a:t>
+              <a:t>Open in one line: "Diya is a meditation kiosk for a museum - a visitor walks up with no</a:t>
+            </a:r>
+          </a:p>
+          <a:p>
+            <a:r>
+              <a:t>staff present, is identified, does a camera-guided session, gets a report, and it resets."</a:t>
+            </a:r>
+          </a:p>
+          <a:p>
+            <a:r>
+              <a:t>Then: I built the software side. ~30 seconds, don't linger.</a:t>
             </a:r>
           </a:p>
         </p:txBody>
@@ -612,60 +595,357 @@
           <a:lstStyle/>
           <a:p>
             <a:r>
-              <a:t>Close by tying back to the opening. Something like:</a:t>
-            </a:r>
-          </a:p>
-          <a:p/>
-          <a:p>
-            <a:r>
-              <a:t>"The kiosk works: someone can walk up, log in with their phone, go through a session and get</a:t>
-            </a:r>
-          </a:p>
-          <a:p>
-            <a:r>
-              <a:t>their report, and it resets itself. The vision hardware is the remaining milestone, and the</a:t>
-            </a:r>
-          </a:p>
-          <a:p>
-            <a:r>
-              <a:t>interfaces for it are in place. Everything I could not finish is written down."</a:t>
-            </a:r>
-          </a:p>
-          <a:p/>
-          <a:p>
-            <a:r>
-              <a:t>Then: "Happy to take questions."</a:t>
-            </a:r>
-          </a:p>
-          <a:p/>
-          <a:p>
-            <a:r>
-              <a:t>Likely questions to have ready:</a:t>
-            </a:r>
-          </a:p>
-          <a:p>
-            <a:r>
-              <a:t> - Why not Electron or a web app?        -&gt; needs local hardware access; managed runtime for uptime</a:t>
-            </a:r>
-          </a:p>
-          <a:p>
-            <a:r>
-              <a:t> - How does the kiosk know the visitor?  -&gt; session token in the QR, roster token on the phone</a:t>
-            </a:r>
-          </a:p>
-          <a:p>
-            <a:r>
-              <a:t> - What happens if the internet drops?   -&gt; the QR path fails; a manual name-entry fallback exists</a:t>
-            </a:r>
-          </a:p>
-          <a:p>
-            <a:r>
-              <a:t> - What was the hardest bug?             -&gt; the Wayland fullscreen one, or the VM clock</a:t>
-            </a:r>
-          </a:p>
-          <a:p>
-            <a:r>
-              <a:t> - What would you do differently?         -&gt; set up CI on day one; write PROJECT.md last, not first</a:t>
+              <a:t>Tell ONE properly, mention the others. The clock one usually lands best because the symptom</a:t>
+            </a:r>
+          </a:p>
+          <a:p>
+            <a:r>
+              <a:t>points completely away from the cause.</a:t>
+            </a:r>
+          </a:p>
+          <a:p>
+            <a:r>
+              <a:t>The Wayland one is better for a technical audience: you would assume a non-resizable window is</a:t>
+            </a:r>
+          </a:p>
+          <a:p>
+            <a:r>
+              <a:t>easier to fullscreen, and it is exactly what prevents it.</a:t>
+            </a:r>
+          </a:p>
+        </p:txBody>
+      </p:sp>
+      <p:sp>
+        <p:nvSpPr>
+          <p:cNvPr id="4" name="Slide Number Placeholder 3"/>
+          <p:cNvSpPr>
+            <a:spLocks noGrp="1"/>
+          </p:cNvSpPr>
+          <p:nvPr>
+            <p:ph type="sldNum" idx="5" sz="quarter"/>
+          </p:nvPr>
+        </p:nvSpPr>
+        <p:spPr/>
+      </p:sp>
+    </p:spTree>
+  </p:cSld>
+  <p:clrMapOvr>
+    <a:masterClrMapping/>
+  </p:clrMapOvr>
+</p:notes>
+</file>
+
+<file path=ppt/notesSlides/notesSlide11.xml><?xml version="1.0" encoding="utf-8"?>
+<p:notes xmlns:a="http://schemas.openxmlformats.org/drawingml/2006/main" xmlns:p="http://schemas.openxmlformats.org/presentationml/2006/main" xmlns:r="http://schemas.openxmlformats.org/officeDocument/2006/relationships">
+  <p:cSld>
+    <p:spTree>
+      <p:nvGrpSpPr>
+        <p:cNvPr id="1" name=""/>
+        <p:cNvGrpSpPr/>
+        <p:nvPr/>
+      </p:nvGrpSpPr>
+      <p:grpSpPr>
+        <a:xfrm>
+          <a:off x="0" y="0"/>
+          <a:ext cx="0" cy="0"/>
+          <a:chOff x="0" y="0"/>
+          <a:chExt cx="0" cy="0"/>
+        </a:xfrm>
+      </p:grpSpPr>
+      <p:sp>
+        <p:nvSpPr>
+          <p:cNvPr id="2" name="Slide Image Placeholder 1"/>
+          <p:cNvSpPr>
+            <a:spLocks noGrp="1"/>
+          </p:cNvSpPr>
+          <p:nvPr>
+            <p:ph type="sldImg" idx="2"/>
+          </p:nvPr>
+        </p:nvSpPr>
+        <p:spPr/>
+      </p:sp>
+      <p:sp>
+        <p:nvSpPr>
+          <p:cNvPr id="3" name="Notes Placeholder 2"/>
+          <p:cNvSpPr>
+            <a:spLocks noGrp="1"/>
+          </p:cNvSpPr>
+          <p:nvPr>
+            <p:ph type="body" idx="3" sz="quarter"/>
+          </p:nvPr>
+        </p:nvSpPr>
+        <p:spPr/>
+        <p:txBody>
+          <a:bodyPr/>
+          <a:lstStyle/>
+          <a:p>
+            <a:r>
+              <a:t>The point: the test kit adds no surface area to the product. No mock classes, no #if DEBUG.</a:t>
+            </a:r>
+          </a:p>
+          <a:p>
+            <a:r>
+              <a:t>It reuses configuration that had to exist anyway for deployment.</a:t>
+            </a:r>
+          </a:p>
+          <a:p>
+            <a:r>
+              <a:t>Mention the stale-PDF bug it surfaced: "show the newest PDF" would quietly show the previous</a:t>
+            </a:r>
+          </a:p>
+          <a:p>
+            <a:r>
+              <a:t>visitor their predecessor's report. Fixed by only accepting a file newer than session start.</a:t>
+            </a:r>
+          </a:p>
+        </p:txBody>
+      </p:sp>
+      <p:sp>
+        <p:nvSpPr>
+          <p:cNvPr id="4" name="Slide Number Placeholder 3"/>
+          <p:cNvSpPr>
+            <a:spLocks noGrp="1"/>
+          </p:cNvSpPr>
+          <p:nvPr>
+            <p:ph type="sldNum" idx="5" sz="quarter"/>
+          </p:nvPr>
+        </p:nvSpPr>
+        <p:spPr/>
+      </p:sp>
+    </p:spTree>
+  </p:cSld>
+  <p:clrMapOvr>
+    <a:masterClrMapping/>
+  </p:clrMapOvr>
+</p:notes>
+</file>
+
+<file path=ppt/notesSlides/notesSlide12.xml><?xml version="1.0" encoding="utf-8"?>
+<p:notes xmlns:a="http://schemas.openxmlformats.org/drawingml/2006/main" xmlns:p="http://schemas.openxmlformats.org/presentationml/2006/main" xmlns:r="http://schemas.openxmlformats.org/officeDocument/2006/relationships">
+  <p:cSld>
+    <p:spTree>
+      <p:nvGrpSpPr>
+        <p:cNvPr id="1" name=""/>
+        <p:cNvGrpSpPr/>
+        <p:nvPr/>
+      </p:nvGrpSpPr>
+      <p:grpSpPr>
+        <a:xfrm>
+          <a:off x="0" y="0"/>
+          <a:ext cx="0" cy="0"/>
+          <a:chOff x="0" y="0"/>
+          <a:chExt cx="0" cy="0"/>
+        </a:xfrm>
+      </p:grpSpPr>
+      <p:sp>
+        <p:nvSpPr>
+          <p:cNvPr id="2" name="Slide Image Placeholder 1"/>
+          <p:cNvSpPr>
+            <a:spLocks noGrp="1"/>
+          </p:cNvSpPr>
+          <p:nvPr>
+            <p:ph type="sldImg" idx="2"/>
+          </p:nvPr>
+        </p:nvSpPr>
+        <p:spPr/>
+      </p:sp>
+      <p:sp>
+        <p:nvSpPr>
+          <p:cNvPr id="3" name="Notes Placeholder 2"/>
+          <p:cNvSpPr>
+            <a:spLocks noGrp="1"/>
+          </p:cNvSpPr>
+          <p:nvPr>
+            <p:ph type="body" idx="3" sz="quarter"/>
+          </p:nvPr>
+        </p:nvSpPr>
+        <p:spPr/>
+        <p:txBody>
+          <a:bodyPr/>
+          <a:lstStyle/>
+          <a:p>
+            <a:r>
+              <a:t>Defend the documentation as engineering work, not paperwork. It records what is invisible in</a:t>
+            </a:r>
+          </a:p>
+          <a:p>
+            <a:r>
+              <a:t>code - why an approach was tried and abandoned, that reinstalling needs the process stopped</a:t>
+            </a:r>
+          </a:p>
+          <a:p>
+            <a:r>
+              <a:t>first, that auto-deploy must be on or merges never go live.</a:t>
+            </a:r>
+          </a:p>
+        </p:txBody>
+      </p:sp>
+      <p:sp>
+        <p:nvSpPr>
+          <p:cNvPr id="4" name="Slide Number Placeholder 3"/>
+          <p:cNvSpPr>
+            <a:spLocks noGrp="1"/>
+          </p:cNvSpPr>
+          <p:nvPr>
+            <p:ph type="sldNum" idx="5" sz="quarter"/>
+          </p:nvPr>
+        </p:nvSpPr>
+        <p:spPr/>
+      </p:sp>
+    </p:spTree>
+  </p:cSld>
+  <p:clrMapOvr>
+    <a:masterClrMapping/>
+  </p:clrMapOvr>
+</p:notes>
+</file>
+
+<file path=ppt/notesSlides/notesSlide13.xml><?xml version="1.0" encoding="utf-8"?>
+<p:notes xmlns:a="http://schemas.openxmlformats.org/drawingml/2006/main" xmlns:p="http://schemas.openxmlformats.org/presentationml/2006/main" xmlns:r="http://schemas.openxmlformats.org/officeDocument/2006/relationships">
+  <p:cSld>
+    <p:spTree>
+      <p:nvGrpSpPr>
+        <p:cNvPr id="1" name=""/>
+        <p:cNvGrpSpPr/>
+        <p:nvPr/>
+      </p:nvGrpSpPr>
+      <p:grpSpPr>
+        <a:xfrm>
+          <a:off x="0" y="0"/>
+          <a:ext cx="0" cy="0"/>
+          <a:chOff x="0" y="0"/>
+          <a:chExt cx="0" cy="0"/>
+        </a:xfrm>
+      </p:grpSpPr>
+      <p:sp>
+        <p:nvSpPr>
+          <p:cNvPr id="2" name="Slide Image Placeholder 1"/>
+          <p:cNvSpPr>
+            <a:spLocks noGrp="1"/>
+          </p:cNvSpPr>
+          <p:nvPr>
+            <p:ph type="sldImg" idx="2"/>
+          </p:nvPr>
+        </p:nvSpPr>
+        <p:spPr/>
+      </p:sp>
+      <p:sp>
+        <p:nvSpPr>
+          <p:cNvPr id="3" name="Notes Placeholder 2"/>
+          <p:cNvSpPr>
+            <a:spLocks noGrp="1"/>
+          </p:cNvSpPr>
+          <p:nvPr>
+            <p:ph type="body" idx="3" sz="quarter"/>
+          </p:nvPr>
+        </p:nvSpPr>
+        <p:spPr/>
+        <p:txBody>
+          <a:bodyPr/>
+          <a:lstStyle/>
+          <a:p>
+            <a:r>
+              <a:t>Do not apologise through this. Stating precisely what is unfinished, and why, is what</a:t>
+            </a:r>
+          </a:p>
+          <a:p>
+            <a:r>
+              <a:t>separates a student demo from a handover.</a:t>
+            </a:r>
+          </a:p>
+          <a:p>
+            <a:r>
+              <a:t>If pressed on personalisation: the launcher starts the pipeline without passing the visitor</a:t>
+            </a:r>
+          </a:p>
+          <a:p>
+            <a:r>
+              <a:t>through, so the report is generic. Small change my side, but it needs their app to read it.</a:t>
+            </a:r>
+          </a:p>
+        </p:txBody>
+      </p:sp>
+      <p:sp>
+        <p:nvSpPr>
+          <p:cNvPr id="4" name="Slide Number Placeholder 3"/>
+          <p:cNvSpPr>
+            <a:spLocks noGrp="1"/>
+          </p:cNvSpPr>
+          <p:nvPr>
+            <p:ph type="sldNum" idx="5" sz="quarter"/>
+          </p:nvPr>
+        </p:nvSpPr>
+        <p:spPr/>
+      </p:sp>
+    </p:spTree>
+  </p:cSld>
+  <p:clrMapOvr>
+    <a:masterClrMapping/>
+  </p:clrMapOvr>
+</p:notes>
+</file>
+
+<file path=ppt/notesSlides/notesSlide14.xml><?xml version="1.0" encoding="utf-8"?>
+<p:notes xmlns:a="http://schemas.openxmlformats.org/drawingml/2006/main" xmlns:p="http://schemas.openxmlformats.org/presentationml/2006/main" xmlns:r="http://schemas.openxmlformats.org/officeDocument/2006/relationships">
+  <p:cSld>
+    <p:spTree>
+      <p:nvGrpSpPr>
+        <p:cNvPr id="1" name=""/>
+        <p:cNvGrpSpPr/>
+        <p:nvPr/>
+      </p:nvGrpSpPr>
+      <p:grpSpPr>
+        <a:xfrm>
+          <a:off x="0" y="0"/>
+          <a:ext cx="0" cy="0"/>
+          <a:chOff x="0" y="0"/>
+          <a:chExt cx="0" cy="0"/>
+        </a:xfrm>
+      </p:grpSpPr>
+      <p:sp>
+        <p:nvSpPr>
+          <p:cNvPr id="2" name="Slide Image Placeholder 1"/>
+          <p:cNvSpPr>
+            <a:spLocks noGrp="1"/>
+          </p:cNvSpPr>
+          <p:nvPr>
+            <p:ph type="sldImg" idx="2"/>
+          </p:nvPr>
+        </p:nvSpPr>
+        <p:spPr/>
+      </p:sp>
+      <p:sp>
+        <p:nvSpPr>
+          <p:cNvPr id="3" name="Notes Placeholder 2"/>
+          <p:cNvSpPr>
+            <a:spLocks noGrp="1"/>
+          </p:cNvSpPr>
+          <p:nvPr>
+            <p:ph type="body" idx="3" sz="quarter"/>
+          </p:nvPr>
+        </p:nvSpPr>
+        <p:spPr/>
+        <p:txBody>
+          <a:bodyPr/>
+          <a:lstStyle/>
+          <a:p>
+            <a:r>
+              <a:t>Tie back to the opening, then stop talking.</a:t>
+            </a:r>
+          </a:p>
+          <a:p>
+            <a:r>
+              <a:t>Likely questions: why not Electron (needs local hardware access); what if the internet drops</a:t>
+            </a:r>
+          </a:p>
+          <a:p>
+            <a:r>
+              <a:t>(QR path fails, manual name entry is the fallback); hardest bug (Wayland fullscreen, or the</a:t>
+            </a:r>
+          </a:p>
+          <a:p>
+            <a:r>
+              <a:t>clock); what would you do differently (CI on day one).</a:t>
             </a:r>
           </a:p>
         </p:txBody>
@@ -735,34 +1015,17 @@
           <a:lstStyle/>
           <a:p>
             <a:r>
-              <a:t>Be explicit about scope early - it stops people assuming you built the computer vision.</a:t>
-            </a:r>
-          </a:p>
-          <a:p/>
-          <a:p>
-            <a:r>
-              <a:t>The line worth landing: "I did not build the vision pipeline. I built everything that has</a:t>
-            </a:r>
-          </a:p>
-          <a:p>
-            <a:r>
-              <a:t>to work before and after it, plus the contract between the two."</a:t>
-            </a:r>
-          </a:p>
-          <a:p/>
-          <a:p>
-            <a:r>
-              <a:t>The thin boundary is a real engineering decision, not a limitation. Because the contract is</a:t>
-            </a:r>
-          </a:p>
-          <a:p>
-            <a:r>
-              <a:t>just 'run this script, then read the newest PDF from this folder', the other team could keep</a:t>
-            </a:r>
-          </a:p>
-          <a:p>
-            <a:r>
-              <a:t>changing their internals all through the internship without ever breaking my app.</a:t>
+              <a:t>The four constraints on the right are the whole design brief. Every one of them ruled</a:t>
+            </a:r>
+          </a:p>
+          <a:p>
+            <a:r>
+              <a:t>something out. "Must never stay closed" is the one people underestimate - an unattended</a:t>
+            </a:r>
+          </a:p>
+          <a:p>
+            <a:r>
+              <a:t>machine that crashes and stays down is worthless.</a:t>
             </a:r>
           </a:p>
         </p:txBody>
@@ -832,38 +1095,17 @@
           <a:lstStyle/>
           <a:p>
             <a:r>
-              <a:t>Why C#/Avalonia, if asked: the kiosk has to drive local hardware on an offline Linux machine,</a:t>
-            </a:r>
-          </a:p>
-          <a:p>
-            <a:r>
-              <a:t>so a pure web app is out. A managed runtime with garbage collection means fewer crash classes</a:t>
-            </a:r>
-          </a:p>
-          <a:p>
-            <a:r>
-              <a:t>for a machine running unattended all day. And Avalonia is the .NET UI framework that actually</a:t>
-            </a:r>
-          </a:p>
-          <a:p>
-            <a:r>
-              <a:t>supports Linux - Microsoft's MAUI does not.</a:t>
-            </a:r>
-          </a:p>
-          <a:p/>
-          <a:p>
-            <a:r>
-              <a:t>Why self-contained single-file: the museum machine should need nothing pre-installed. I also</a:t>
-            </a:r>
-          </a:p>
-          <a:p>
-            <a:r>
-              <a:t>set InvariantGlobalization=true to drop the libicu dependency, so one .deb installs across</a:t>
-            </a:r>
-          </a:p>
-          <a:p>
-            <a:r>
-              <a:t>different Ubuntu releases instead of needing a build per version.</a:t>
+              <a:t>Say the scope split explicitly so nobody assumes you built the computer vision.</a:t>
+            </a:r>
+          </a:p>
+          <a:p>
+            <a:r>
+              <a:t>The line to land is the gold box: the seam is two primitives, not a protocol. That is why</a:t>
+            </a:r>
+          </a:p>
+          <a:p>
+            <a:r>
+              <a:t>the other team could change their internals all summer without breaking me.</a:t>
             </a:r>
           </a:p>
         </p:txBody>
@@ -933,54 +1175,17 @@
           <a:lstStyle/>
           <a:p>
             <a:r>
-              <a:t>This is the slide to slow down on. It is the strongest thing in the project because the</a:t>
-            </a:r>
-          </a:p>
-          <a:p>
-            <a:r>
-              <a:t>solution came out of a constraint rather than around it.</a:t>
-            </a:r>
-          </a:p>
-          <a:p/>
-          <a:p>
-            <a:r>
-              <a:t>Walk the final flow concretely:</a:t>
-            </a:r>
-          </a:p>
-          <a:p>
-            <a:r>
-              <a:t>  POST /api/sessions       kiosk gets a short random token</a:t>
-            </a:r>
-          </a:p>
-          <a:p>
-            <a:r>
-              <a:t>  it renders &lt;site&gt;/?session=&lt;token&gt; as a QR on screen</a:t>
-            </a:r>
-          </a:p>
-          <a:p>
-            <a:r>
-              <a:t>  the visitor's phone opens that URL and claims the session</a:t>
-            </a:r>
-          </a:p>
-          <a:p>
-            <a:r>
-              <a:t>  the kiosk is polling GET /api/sessions/:token every 2 seconds and advances on 'claimed'</a:t>
-            </a:r>
-          </a:p>
-          <a:p/>
-          <a:p>
-            <a:r>
-              <a:t>If asked why not just a touchscreen keyboard: people mistype, it needs cleaning between</a:t>
-            </a:r>
-          </a:p>
-          <a:p>
-            <a:r>
-              <a:t>visitors, and it cannot verify identity against a roster. The phone already is a trusted,</a:t>
-            </a:r>
-          </a:p>
-          <a:p>
-            <a:r>
-              <a:t>personal, camera-equipped input device - so use it.</a:t>
+              <a:t>Pause here. This is the question the whole project turns on.</a:t>
+            </a:r>
+          </a:p>
+          <a:p>
+            <a:r>
+              <a:t>If asked why not a touchscreen keyboard: people mistype, it needs cleaning between</a:t>
+            </a:r>
+          </a:p>
+          <a:p>
+            <a:r>
+              <a:t>strangers, and it cannot verify anyone against a roster.</a:t>
             </a:r>
           </a:p>
         </p:txBody>
@@ -1050,39 +1255,17 @@
           <a:lstStyle/>
           <a:p>
             <a:r>
-              <a:t>Two details worth mentioning because they show real-world thinking rather than demo-thinking:</a:t>
-            </a:r>
-          </a:p>
-          <a:p/>
-          <a:p>
-            <a:r>
-              <a:t>1. Loose header matching. Real spreadsheets never have clean column names. Headers are</a:t>
-            </a:r>
-          </a:p>
-          <a:p>
-            <a:r>
-              <a:t>   normalised and substring-matched, so 'Email Id', 'Email Address' and</a:t>
-            </a:r>
-          </a:p>
-          <a:p>
-            <a:r>
-              <a:t>   'Image Link (Gdrive - view only)' all resolve correctly. Only Name is required.</a:t>
-            </a:r>
-          </a:p>
-          <a:p/>
-          <a:p>
-            <a:r>
-              <a:t>2. The photo loads fail-open. It downloads in the background, and a missing, broken or</a:t>
-            </a:r>
-          </a:p>
-          <a:p>
-            <a:r>
-              <a:t>   unsupported image just leaves the avatar hidden - it can never block or crash the flow.</a:t>
-            </a:r>
-          </a:p>
-          <a:p>
-            <a:r>
-              <a:t>   On a kiosk, a cosmetic asset must never be on the critical path.</a:t>
+              <a:t>Walk left to right - the value is in showing you iterated, not that you guessed right.</a:t>
+            </a:r>
+          </a:p>
+          <a:p>
+            <a:r>
+              <a:t>Attempt 1 worked offline but needed a reader. Attempt 2 fixed privacy, same hardware problem.</a:t>
+            </a:r>
+          </a:p>
+          <a:p>
+            <a:r>
+              <a:t>Attempt 3 removed the hardware entirely.</a:t>
             </a:r>
           </a:p>
         </p:txBody>
@@ -1152,44 +1335,22 @@
           <a:lstStyle/>
           <a:p>
             <a:r>
-              <a:t>Pick ONE of these to tell properly and mention the others. The clock one is usually the</a:t>
-            </a:r>
-          </a:p>
-          <a:p>
-            <a:r>
-              <a:t>crowd-pleaser because the symptom points completely away from the cause.</a:t>
-            </a:r>
-          </a:p>
-          <a:p/>
-          <a:p>
-            <a:r>
-              <a:t>The fullscreen bug is the better answer if your audience is technical: the intuition is</a:t>
-            </a:r>
-          </a:p>
-          <a:p>
-            <a:r>
-              <a:t>backwards. You would assume a non-resizable window is easier to fullscreen. In fact</a:t>
-            </a:r>
-          </a:p>
-          <a:p>
-            <a:r>
-              <a:t>CanResize=False is exactly what stops it, because mutter honours the fixed size hints</a:t>
-            </a:r>
-          </a:p>
-          <a:p>
-            <a:r>
-              <a:t>over the fullscreen request.</a:t>
-            </a:r>
-          </a:p>
-          <a:p/>
-          <a:p>
-            <a:r>
-              <a:t>If asked how you found it: narrowed it by changing one window property at a time and</a:t>
-            </a:r>
-          </a:p>
-          <a:p>
-            <a:r>
-              <a:t>logging WindowState and ClientSize on every attempt.</a:t>
+              <a:t>The strongest slide. Slow down.</a:t>
+            </a:r>
+          </a:p>
+          <a:p>
+            <a:r>
+              <a:t>The kiosk creates a session, renders the token as a QR, and polls. The phone reads it.</a:t>
+            </a:r>
+          </a:p>
+          <a:p>
+            <a:r>
+              <a:t>The phone is already a trusted, personal, camera-equipped input device - so use it.</a:t>
+            </a:r>
+          </a:p>
+          <a:p>
+            <a:r>
+              <a:t>Closing line: a constraint produced a simpler design than a budget would have.</a:t>
             </a:r>
           </a:p>
         </p:txBody>
@@ -1259,38 +1420,22 @@
           <a:lstStyle/>
           <a:p>
             <a:r>
-              <a:t>The point to make: the test kit adds no surface area to the product. It reuses configuration</a:t>
-            </a:r>
-          </a:p>
-          <a:p>
-            <a:r>
-              <a:t>that already had to exist for deployment flexibility. That is why there is no #if DEBUG and</a:t>
-            </a:r>
-          </a:p>
-          <a:p>
-            <a:r>
-              <a:t>no mock class anywhere in the app.</a:t>
-            </a:r>
-          </a:p>
-          <a:p/>
-          <a:p>
-            <a:r>
-              <a:t>The stale-PDF bug is worth a sentence of its own. The naive version is 'show the newest PDF</a:t>
-            </a:r>
-          </a:p>
-          <a:p>
-            <a:r>
-              <a:t>in the folder'. If the pipeline fails without writing one, that quietly shows the PREVIOUS</a:t>
-            </a:r>
-          </a:p>
-          <a:p>
-            <a:r>
-              <a:t>visitor their predecessor's report - a privacy failure that looks like success. The fix is to</a:t>
-            </a:r>
-          </a:p>
-          <a:p>
-            <a:r>
-              <a:t>record the time the session started and only accept a file newer than that.</a:t>
+              <a:t>This is the architecture answer. Four stages, and note stage 3 is highlighted for a reason:</a:t>
+            </a:r>
+          </a:p>
+          <a:p>
+            <a:r>
+              <a:t>it is the only boundary that is NOT an API. One shell script, one PDF on disk.</a:t>
+            </a:r>
+          </a:p>
+          <a:p>
+            <a:r>
+              <a:t>If asked "why not an API there too" - because a protocol is a thing that can break, and</a:t>
+            </a:r>
+          </a:p>
+          <a:p>
+            <a:r>
+              <a:t>their code was changing weekly.</a:t>
             </a:r>
           </a:p>
         </p:txBody>
@@ -1360,33 +1505,22 @@
           <a:lstStyle/>
           <a:p>
             <a:r>
-              <a:t>The handoff documentation is worth defending as engineering work, not paperwork. It records</a:t>
-            </a:r>
-          </a:p>
-          <a:p>
-            <a:r>
-              <a:t>things that are invisible in the code: why the self-minimise approach was tried and abandoned,</a:t>
-            </a:r>
-          </a:p>
-          <a:p>
-            <a:r>
-              <a:t>that reinstalling the .deb requires stopping the running process first, that the hosting</a:t>
-            </a:r>
-          </a:p>
-          <a:p>
-            <a:r>
-              <a:t>service must have auto-deploy enabled or merges silently never go live.</a:t>
-            </a:r>
-          </a:p>
-          <a:p/>
-          <a:p>
-            <a:r>
-              <a:t>If you want one line here: "I wrote the docs assuming the next person would be someone who</a:t>
-            </a:r>
-          </a:p>
-          <a:p>
-            <a:r>
-              <a:t>had never spoken to me."</a:t>
+              <a:t>These are real frames from the running app, not mockups.</a:t>
+            </a:r>
+          </a:p>
+          <a:p>
+            <a:r>
+              <a:t>Left: the claim resolved, name and roster photo fetched, session auto-started.</a:t>
+            </a:r>
+          </a:p>
+          <a:p>
+            <a:r>
+              <a:t>Right: the PDF decoded and rendered in-app - no external viewer, desktop never visible.</a:t>
+            </a:r>
+          </a:p>
+          <a:p>
+            <a:r>
+              <a:t>Be ready to say the report PDF shown is representative; the real one comes from their app.</a:t>
             </a:r>
           </a:p>
         </p:txBody>
@@ -1456,49 +1590,22 @@
           <a:lstStyle/>
           <a:p>
             <a:r>
-              <a:t>Do not rush this slide or apologise through it. Being able to state precisely what is</a:t>
-            </a:r>
-          </a:p>
-          <a:p>
-            <a:r>
-              <a:t>unfinished, and why, is the difference between a student demo and an engineering handover.</a:t>
-            </a:r>
-          </a:p>
-          <a:p/>
-          <a:p>
-            <a:r>
-              <a:t>If someone presses on the personalisation gap, own it cleanly: the launcher currently starts</a:t>
-            </a:r>
-          </a:p>
-          <a:p>
-            <a:r>
-              <a:t>the pipeline without passing the visitor through, so the report is generic. The fix is to pass</a:t>
-            </a:r>
-          </a:p>
-          <a:p>
-            <a:r>
-              <a:t>identity via environment variables into the script - small change on my side, but it needs the</a:t>
-            </a:r>
-          </a:p>
-          <a:p>
-            <a:r>
-              <a:t>other team to read it, so it is a coordination item rather than a code item.</a:t>
-            </a:r>
-          </a:p>
-          <a:p/>
-          <a:p>
-            <a:r>
-              <a:t>Recommended order if asked what you would do next:</a:t>
-            </a:r>
-          </a:p>
-          <a:p>
-            <a:r>
-              <a:t>timeout + failure screen first (it is the one that can strand the kiosk), then pass identity</a:t>
-            </a:r>
-          </a:p>
-          <a:p>
-            <a:r>
-              <a:t>through, then the consent screen, then CI for the packages.</a:t>
+              <a:t>Keep this brief - it is reference, not narrative.</a:t>
+            </a:r>
+          </a:p>
+          <a:p>
+            <a:r>
+              <a:t>If asked why C#/Avalonia: the kiosk drives local hardware on offline Linux, so a web app is</a:t>
+            </a:r>
+          </a:p>
+          <a:p>
+            <a:r>
+              <a:t>out; a managed runtime means fewer crash classes for all-day unattended operation; and</a:t>
+            </a:r>
+          </a:p>
+          <a:p>
+            <a:r>
+              <a:t>Avalonia is the .NET UI framework that actually supports Linux.</a:t>
             </a:r>
           </a:p>
         </p:txBody>
@@ -4497,14 +4604,6 @@
 <file path=ppt/slides/slide1.xml><?xml version="1.0" encoding="utf-8"?>
 <p:sld xmlns:a="http://schemas.openxmlformats.org/drawingml/2006/main" xmlns:p="http://schemas.openxmlformats.org/presentationml/2006/main" xmlns:r="http://schemas.openxmlformats.org/officeDocument/2006/relationships">
   <p:cSld>
-    <p:bg>
-      <p:bgPr>
-        <a:solidFill>
-          <a:srgbClr val="1A1330"/>
-        </a:solidFill>
-        <a:effectLst/>
-      </p:bgPr>
-    </p:bg>
     <p:spTree>
       <p:nvGrpSpPr>
         <p:cNvPr id="1" name=""/>
@@ -4512,248 +4611,30 @@
         <p:nvPr/>
       </p:nvGrpSpPr>
       <p:grpSpPr/>
-      <p:sp>
-        <p:nvSpPr>
-          <p:cNvPr id="2" name="TextBox 1"/>
-          <p:cNvSpPr txBox="1"/>
+      <p:pic>
+        <p:nvPicPr>
+          <p:cNvPr id="2" name="Picture 1" descr="slide-01.png"/>
+          <p:cNvPicPr>
+            <a:picLocks noChangeAspect="1"/>
+          </p:cNvPicPr>
           <p:nvPr/>
-        </p:nvSpPr>
+        </p:nvPicPr>
+        <p:blipFill>
+          <a:blip r:embed="rId2"/>
+          <a:stretch>
+            <a:fillRect/>
+          </a:stretch>
+        </p:blipFill>
         <p:spPr>
           <a:xfrm>
-            <a:off x="777240" y="2057400"/>
-            <a:ext cx="10637215" cy="914400"/>
+            <a:off x="0" y="0"/>
+            <a:ext cx="12191695" cy="6858000"/>
           </a:xfrm>
           <a:prstGeom prst="rect">
             <a:avLst/>
           </a:prstGeom>
-          <a:noFill/>
         </p:spPr>
-        <p:txBody>
-          <a:bodyPr wrap="square">
-            <a:spAutoFit/>
-          </a:bodyPr>
-          <a:lstStyle/>
-          <a:p>
-            <a:pPr algn="l">
-              <a:spcBef>
-                <a:spcPts val="0"/>
-              </a:spcBef>
-              <a:spcAft>
-                <a:spcPts val="1000"/>
-              </a:spcAft>
-            </a:pPr>
-            <a:r>
-              <a:rPr sz="1300" b="1" i="0">
-                <a:solidFill>
-                  <a:srgbClr val="E9B872"/>
-                </a:solidFill>
-                <a:latin typeface="Calibri"/>
-              </a:rPr>
-              <a:t>DIYA</a:t>
-            </a:r>
-          </a:p>
-        </p:txBody>
-      </p:sp>
-      <p:sp>
-        <p:nvSpPr>
-          <p:cNvPr id="3" name="TextBox 2"/>
-          <p:cNvSpPr txBox="1"/>
-          <p:nvPr/>
-        </p:nvSpPr>
-        <p:spPr>
-          <a:xfrm>
-            <a:off x="777240" y="2377440"/>
-            <a:ext cx="9601200" cy="1463040"/>
-          </a:xfrm>
-          <a:prstGeom prst="rect">
-            <a:avLst/>
-          </a:prstGeom>
-          <a:noFill/>
-        </p:spPr>
-        <p:txBody>
-          <a:bodyPr wrap="square">
-            <a:spAutoFit/>
-          </a:bodyPr>
-          <a:lstStyle/>
-          <a:p>
-            <a:pPr algn="l">
-              <a:spcBef>
-                <a:spcPts val="0"/>
-              </a:spcBef>
-              <a:spcAft>
-                <a:spcPts val="0"/>
-              </a:spcAft>
-            </a:pPr>
-            <a:r>
-              <a:rPr sz="4000" b="1" i="0">
-                <a:solidFill>
-                  <a:srgbClr val="FFFFFF"/>
-                </a:solidFill>
-                <a:latin typeface="Calibri"/>
-              </a:rPr>
-              <a:t>An Unattended Meditation Kiosk</a:t>
-            </a:r>
-          </a:p>
-        </p:txBody>
-      </p:sp>
-      <p:sp>
-        <p:nvSpPr>
-          <p:cNvPr id="4" name="Rectangle 3"/>
-          <p:cNvSpPr/>
-          <p:nvPr/>
-        </p:nvSpPr>
-        <p:spPr>
-          <a:xfrm>
-            <a:off x="777240" y="3886200"/>
-            <a:ext cx="1645920" cy="50800"/>
-          </a:xfrm>
-          <a:prstGeom prst="rect">
-            <a:avLst/>
-          </a:prstGeom>
-          <a:solidFill>
-            <a:srgbClr val="E9B872"/>
-          </a:solidFill>
-          <a:ln>
-            <a:noFill/>
-          </a:ln>
-          <a:effectLst/>
-        </p:spPr>
-        <p:style>
-          <a:lnRef idx="1">
-            <a:schemeClr val="accent1"/>
-          </a:lnRef>
-          <a:fillRef idx="3">
-            <a:schemeClr val="accent1"/>
-          </a:fillRef>
-          <a:effectRef idx="2">
-            <a:schemeClr val="accent1"/>
-          </a:effectRef>
-          <a:fontRef idx="minor">
-            <a:schemeClr val="lt1"/>
-          </a:fontRef>
-        </p:style>
-        <p:txBody>
-          <a:bodyPr rtlCol="0" anchor="ctr"/>
-          <a:lstStyle/>
-          <a:p>
-            <a:pPr algn="ctr"/>
-          </a:p>
-        </p:txBody>
-      </p:sp>
-      <p:sp>
-        <p:nvSpPr>
-          <p:cNvPr id="5" name="TextBox 4"/>
-          <p:cNvSpPr txBox="1"/>
-          <p:nvPr/>
-        </p:nvSpPr>
-        <p:spPr>
-          <a:xfrm>
-            <a:off x="777240" y="4160520"/>
-            <a:ext cx="9601200" cy="1097280"/>
-          </a:xfrm>
-          <a:prstGeom prst="rect">
-            <a:avLst/>
-          </a:prstGeom>
-          <a:noFill/>
-        </p:spPr>
-        <p:txBody>
-          <a:bodyPr wrap="square">
-            <a:spAutoFit/>
-          </a:bodyPr>
-          <a:lstStyle/>
-          <a:p>
-            <a:pPr algn="l">
-              <a:spcBef>
-                <a:spcPts val="0"/>
-              </a:spcBef>
-              <a:spcAft>
-                <a:spcPts val="1400"/>
-              </a:spcAft>
-            </a:pPr>
-            <a:r>
-              <a:rPr sz="1600" b="0" i="0">
-                <a:solidFill>
-                  <a:srgbClr val="B4A9D6"/>
-                </a:solidFill>
-                <a:latin typeface="Calibri"/>
-              </a:rPr>
-              <a:t>Linux kiosk application, registration backend, and deployment tooling</a:t>
-            </a:r>
-          </a:p>
-          <a:p>
-            <a:pPr algn="l">
-              <a:spcBef>
-                <a:spcPts val="0"/>
-              </a:spcBef>
-              <a:spcAft>
-                <a:spcPts val="300"/>
-              </a:spcAft>
-            </a:pPr>
-            <a:r>
-              <a:rPr sz="1300" b="0" i="0">
-                <a:solidFill>
-                  <a:srgbClr val="8F83B8"/>
-                </a:solidFill>
-                <a:latin typeface="Calibri"/>
-              </a:rPr>
-              <a:t>[Your Name]   ·   [Institution]   ·   [Month Year – Month Year]</a:t>
-            </a:r>
-          </a:p>
-          <a:p>
-            <a:pPr algn="l">
-              <a:spcBef>
-                <a:spcPts val="0"/>
-              </a:spcBef>
-              <a:spcAft>
-                <a:spcPts val="600"/>
-              </a:spcAft>
-            </a:pPr>
-            <a:r>
-              <a:rPr sz="1300" b="0" i="0">
-                <a:solidFill>
-                  <a:srgbClr val="8F83B8"/>
-                </a:solidFill>
-                <a:latin typeface="Calibri"/>
-              </a:rPr>
-              <a:t>Guide: [Mentor Name]</a:t>
-            </a:r>
-          </a:p>
-        </p:txBody>
-      </p:sp>
-      <p:sp>
-        <p:nvSpPr>
-          <p:cNvPr id="6" name="TextBox 5"/>
-          <p:cNvSpPr txBox="1"/>
-          <p:nvPr/>
-        </p:nvSpPr>
-        <p:spPr>
-          <a:xfrm>
-            <a:off x="777240" y="6291072"/>
-            <a:ext cx="10637215" cy="320040"/>
-          </a:xfrm>
-          <a:prstGeom prst="rect">
-            <a:avLst/>
-          </a:prstGeom>
-          <a:noFill/>
-        </p:spPr>
-        <p:txBody>
-          <a:bodyPr wrap="square">
-            <a:spAutoFit/>
-          </a:bodyPr>
-          <a:lstStyle/>
-          <a:p>
-            <a:r>
-              <a:rPr sz="1000">
-                <a:solidFill>
-                  <a:srgbClr val="9CA3AF"/>
-                </a:solidFill>
-                <a:latin typeface="Calibri"/>
-              </a:rPr>
-              <a:t>Diya Meditation Kiosk  ·  Internship Report          </a:t>
-            </a:r>
-          </a:p>
-        </p:txBody>
-      </p:sp>
+      </p:pic>
     </p:spTree>
   </p:cSld>
   <p:clrMapOvr>
@@ -4772,301 +4653,198 @@
         <p:nvPr/>
       </p:nvGrpSpPr>
       <p:grpSpPr/>
-      <p:sp>
-        <p:nvSpPr>
-          <p:cNvPr id="2" name="TextBox 1"/>
-          <p:cNvSpPr txBox="1"/>
+      <p:pic>
+        <p:nvPicPr>
+          <p:cNvPr id="2" name="Picture 1" descr="slide-10.png"/>
+          <p:cNvPicPr>
+            <a:picLocks noChangeAspect="1"/>
+          </p:cNvPicPr>
           <p:nvPr/>
-        </p:nvSpPr>
+        </p:nvPicPr>
+        <p:blipFill>
+          <a:blip r:embed="rId2"/>
+          <a:stretch>
+            <a:fillRect/>
+          </a:stretch>
+        </p:blipFill>
         <p:spPr>
           <a:xfrm>
-            <a:off x="777240" y="502920"/>
-            <a:ext cx="10637215" cy="274320"/>
+            <a:off x="0" y="0"/>
+            <a:ext cx="12191695" cy="6858000"/>
           </a:xfrm>
           <a:prstGeom prst="rect">
             <a:avLst/>
           </a:prstGeom>
-          <a:noFill/>
         </p:spPr>
-        <p:txBody>
-          <a:bodyPr wrap="square">
-            <a:spAutoFit/>
-          </a:bodyPr>
-          <a:lstStyle/>
-          <a:p>
-            <a:pPr algn="l">
-              <a:spcBef>
-                <a:spcPts val="0"/>
-              </a:spcBef>
-              <a:spcAft>
-                <a:spcPts val="0"/>
-              </a:spcAft>
-            </a:pPr>
-            <a:r>
-              <a:rPr sz="1100" b="1" i="0">
-                <a:solidFill>
-                  <a:srgbClr val="E9B872"/>
-                </a:solidFill>
-                <a:latin typeface="Calibri"/>
-              </a:rPr>
-              <a:t>REFLECTION</a:t>
-            </a:r>
-          </a:p>
-        </p:txBody>
-      </p:sp>
-      <p:sp>
-        <p:nvSpPr>
-          <p:cNvPr id="3" name="TextBox 2"/>
-          <p:cNvSpPr txBox="1"/>
+      </p:pic>
+    </p:spTree>
+  </p:cSld>
+  <p:clrMapOvr>
+    <a:masterClrMapping/>
+  </p:clrMapOvr>
+</p:sld>
+</file>
+
+<file path=ppt/slides/slide11.xml><?xml version="1.0" encoding="utf-8"?>
+<p:sld xmlns:a="http://schemas.openxmlformats.org/drawingml/2006/main" xmlns:p="http://schemas.openxmlformats.org/presentationml/2006/main" xmlns:r="http://schemas.openxmlformats.org/officeDocument/2006/relationships">
+  <p:cSld>
+    <p:spTree>
+      <p:nvGrpSpPr>
+        <p:cNvPr id="1" name=""/>
+        <p:cNvGrpSpPr/>
+        <p:nvPr/>
+      </p:nvGrpSpPr>
+      <p:grpSpPr/>
+      <p:pic>
+        <p:nvPicPr>
+          <p:cNvPr id="2" name="Picture 1" descr="slide-11.png"/>
+          <p:cNvPicPr>
+            <a:picLocks noChangeAspect="1"/>
+          </p:cNvPicPr>
           <p:nvPr/>
-        </p:nvSpPr>
+        </p:nvPicPr>
+        <p:blipFill>
+          <a:blip r:embed="rId2"/>
+          <a:stretch>
+            <a:fillRect/>
+          </a:stretch>
+        </p:blipFill>
         <p:spPr>
           <a:xfrm>
-            <a:off x="777240" y="777240"/>
-            <a:ext cx="10637215" cy="640080"/>
+            <a:off x="0" y="0"/>
+            <a:ext cx="12191695" cy="6858000"/>
           </a:xfrm>
           <a:prstGeom prst="rect">
             <a:avLst/>
           </a:prstGeom>
-          <a:noFill/>
         </p:spPr>
-        <p:txBody>
-          <a:bodyPr wrap="square">
-            <a:spAutoFit/>
-          </a:bodyPr>
-          <a:lstStyle/>
-          <a:p>
-            <a:pPr algn="l">
-              <a:spcBef>
-                <a:spcPts val="0"/>
-              </a:spcBef>
-              <a:spcAft>
-                <a:spcPts val="0"/>
-              </a:spcAft>
-            </a:pPr>
-            <a:r>
-              <a:rPr sz="3000" b="1" i="0">
-                <a:solidFill>
-                  <a:srgbClr val="1A1330"/>
-                </a:solidFill>
-                <a:latin typeface="Calibri"/>
-              </a:rPr>
-              <a:t>What I Took Away</a:t>
-            </a:r>
-          </a:p>
-        </p:txBody>
-      </p:sp>
-      <p:sp>
-        <p:nvSpPr>
-          <p:cNvPr id="4" name="Rectangle 3"/>
-          <p:cNvSpPr/>
+      </p:pic>
+    </p:spTree>
+  </p:cSld>
+  <p:clrMapOvr>
+    <a:masterClrMapping/>
+  </p:clrMapOvr>
+</p:sld>
+</file>
+
+<file path=ppt/slides/slide12.xml><?xml version="1.0" encoding="utf-8"?>
+<p:sld xmlns:a="http://schemas.openxmlformats.org/drawingml/2006/main" xmlns:p="http://schemas.openxmlformats.org/presentationml/2006/main" xmlns:r="http://schemas.openxmlformats.org/officeDocument/2006/relationships">
+  <p:cSld>
+    <p:spTree>
+      <p:nvGrpSpPr>
+        <p:cNvPr id="1" name=""/>
+        <p:cNvGrpSpPr/>
+        <p:nvPr/>
+      </p:nvGrpSpPr>
+      <p:grpSpPr/>
+      <p:pic>
+        <p:nvPicPr>
+          <p:cNvPr id="2" name="Picture 1" descr="slide-12.png"/>
+          <p:cNvPicPr>
+            <a:picLocks noChangeAspect="1"/>
+          </p:cNvPicPr>
           <p:nvPr/>
-        </p:nvSpPr>
+        </p:nvPicPr>
+        <p:blipFill>
+          <a:blip r:embed="rId2"/>
+          <a:stretch>
+            <a:fillRect/>
+          </a:stretch>
+        </p:blipFill>
         <p:spPr>
           <a:xfrm>
-            <a:off x="777240" y="1481328"/>
-            <a:ext cx="1371600" cy="50800"/>
+            <a:off x="0" y="0"/>
+            <a:ext cx="12191695" cy="6858000"/>
           </a:xfrm>
           <a:prstGeom prst="rect">
             <a:avLst/>
           </a:prstGeom>
-          <a:solidFill>
-            <a:srgbClr val="E9B872"/>
-          </a:solidFill>
-          <a:ln>
-            <a:noFill/>
-          </a:ln>
-          <a:effectLst/>
         </p:spPr>
-        <p:style>
-          <a:lnRef idx="1">
-            <a:schemeClr val="accent1"/>
-          </a:lnRef>
-          <a:fillRef idx="3">
-            <a:schemeClr val="accent1"/>
-          </a:fillRef>
-          <a:effectRef idx="2">
-            <a:schemeClr val="accent1"/>
-          </a:effectRef>
-          <a:fontRef idx="minor">
-            <a:schemeClr val="lt1"/>
-          </a:fontRef>
-        </p:style>
-        <p:txBody>
-          <a:bodyPr rtlCol="0" anchor="ctr"/>
-          <a:lstStyle/>
-          <a:p>
-            <a:pPr algn="ctr"/>
-          </a:p>
-        </p:txBody>
-      </p:sp>
-      <p:sp>
-        <p:nvSpPr>
-          <p:cNvPr id="5" name="TextBox 4"/>
-          <p:cNvSpPr txBox="1"/>
+      </p:pic>
+    </p:spTree>
+  </p:cSld>
+  <p:clrMapOvr>
+    <a:masterClrMapping/>
+  </p:clrMapOvr>
+</p:sld>
+</file>
+
+<file path=ppt/slides/slide13.xml><?xml version="1.0" encoding="utf-8"?>
+<p:sld xmlns:a="http://schemas.openxmlformats.org/drawingml/2006/main" xmlns:p="http://schemas.openxmlformats.org/presentationml/2006/main" xmlns:r="http://schemas.openxmlformats.org/officeDocument/2006/relationships">
+  <p:cSld>
+    <p:spTree>
+      <p:nvGrpSpPr>
+        <p:cNvPr id="1" name=""/>
+        <p:cNvGrpSpPr/>
+        <p:nvPr/>
+      </p:nvGrpSpPr>
+      <p:grpSpPr/>
+      <p:pic>
+        <p:nvPicPr>
+          <p:cNvPr id="2" name="Picture 1" descr="slide-13.png"/>
+          <p:cNvPicPr>
+            <a:picLocks noChangeAspect="1"/>
+          </p:cNvPicPr>
           <p:nvPr/>
-        </p:nvSpPr>
+        </p:nvPicPr>
+        <p:blipFill>
+          <a:blip r:embed="rId2"/>
+          <a:stretch>
+            <a:fillRect/>
+          </a:stretch>
+        </p:blipFill>
         <p:spPr>
           <a:xfrm>
-            <a:off x="777240" y="1783080"/>
-            <a:ext cx="10637215" cy="4389120"/>
+            <a:off x="0" y="0"/>
+            <a:ext cx="12191695" cy="6858000"/>
           </a:xfrm>
           <a:prstGeom prst="rect">
             <a:avLst/>
           </a:prstGeom>
-          <a:noFill/>
         </p:spPr>
-        <p:txBody>
-          <a:bodyPr wrap="square">
-            <a:spAutoFit/>
-          </a:bodyPr>
-          <a:lstStyle/>
-          <a:p>
-            <a:pPr algn="l">
-              <a:lnSpc>
-                <a:spcPct val="115000"/>
-              </a:lnSpc>
-              <a:spcBef>
-                <a:spcPts val="0"/>
-              </a:spcBef>
-              <a:spcAft>
-                <a:spcPts val="700"/>
-              </a:spcAft>
-            </a:pPr>
-            <a:r>
-              <a:rPr sz="1500" b="0" i="0">
-                <a:solidFill>
-                  <a:srgbClr val="374151"/>
-                </a:solidFill>
-                <a:latin typeface="Calibri"/>
-              </a:rPr>
-              <a:t>•   Constraints produce better designs. Having no scanner hardware is what led to the inverted QR flow — simpler than what I'd have built with a budget.</a:t>
-            </a:r>
-          </a:p>
-          <a:p>
-            <a:pPr algn="l">
-              <a:lnSpc>
-                <a:spcPct val="115000"/>
-              </a:lnSpc>
-              <a:spcBef>
-                <a:spcPts val="0"/>
-              </a:spcBef>
-              <a:spcAft>
-                <a:spcPts val="700"/>
-              </a:spcAft>
-            </a:pPr>
-            <a:r>
-              <a:rPr sz="1500" b="0" i="0">
-                <a:solidFill>
-                  <a:srgbClr val="374151"/>
-                </a:solidFill>
-                <a:latin typeface="Calibri"/>
-              </a:rPr>
-              <a:t>•   On Linux desktop, the window manager is a dependency. It has opinions, and you have to test against the real compositor.</a:t>
-            </a:r>
-          </a:p>
-          <a:p>
-            <a:pPr algn="l">
-              <a:lnSpc>
-                <a:spcPct val="115000"/>
-              </a:lnSpc>
-              <a:spcBef>
-                <a:spcPts val="0"/>
-              </a:spcBef>
-              <a:spcAft>
-                <a:spcPts val="700"/>
-              </a:spcAft>
-            </a:pPr>
-            <a:r>
-              <a:rPr sz="1500" b="0" i="0">
-                <a:solidFill>
-                  <a:srgbClr val="374151"/>
-                </a:solidFill>
-                <a:latin typeface="Calibri"/>
-              </a:rPr>
-              <a:t>•   Keep integration boundaries boring. One script and one directory meant the other team could change everything internally without breaking me.</a:t>
-            </a:r>
-          </a:p>
-          <a:p>
-            <a:pPr algn="l">
-              <a:lnSpc>
-                <a:spcPct val="115000"/>
-              </a:lnSpc>
-              <a:spcBef>
-                <a:spcPts val="0"/>
-              </a:spcBef>
-              <a:spcAft>
-                <a:spcPts val="700"/>
-              </a:spcAft>
-            </a:pPr>
-            <a:r>
-              <a:rPr sz="1500" b="0" i="0">
-                <a:solidFill>
-                  <a:srgbClr val="374151"/>
-                </a:solidFill>
-                <a:latin typeface="Calibri"/>
-              </a:rPr>
-              <a:t>•   On an unattended machine, every failure needs a visible state. Anything that can hang forever eventually will.</a:t>
-            </a:r>
-          </a:p>
-          <a:p>
-            <a:pPr algn="l">
-              <a:lnSpc>
-                <a:spcPct val="115000"/>
-              </a:lnSpc>
-              <a:spcBef>
-                <a:spcPts val="0"/>
-              </a:spcBef>
-              <a:spcAft>
-                <a:spcPts val="700"/>
-              </a:spcAft>
-            </a:pPr>
-            <a:r>
-              <a:rPr sz="1500" b="0" i="0">
-                <a:solidFill>
-                  <a:srgbClr val="374151"/>
-                </a:solidFill>
-                <a:latin typeface="Calibri"/>
-              </a:rPr>
-              <a:t>•   Documentation drifts faster than code. Separate what is built from what is planned, or the next person trusts the wrong page.</a:t>
-            </a:r>
-          </a:p>
-        </p:txBody>
-      </p:sp>
-      <p:sp>
-        <p:nvSpPr>
-          <p:cNvPr id="6" name="TextBox 5"/>
-          <p:cNvSpPr txBox="1"/>
+      </p:pic>
+    </p:spTree>
+  </p:cSld>
+  <p:clrMapOvr>
+    <a:masterClrMapping/>
+  </p:clrMapOvr>
+</p:sld>
+</file>
+
+<file path=ppt/slides/slide14.xml><?xml version="1.0" encoding="utf-8"?>
+<p:sld xmlns:a="http://schemas.openxmlformats.org/drawingml/2006/main" xmlns:p="http://schemas.openxmlformats.org/presentationml/2006/main" xmlns:r="http://schemas.openxmlformats.org/officeDocument/2006/relationships">
+  <p:cSld>
+    <p:spTree>
+      <p:nvGrpSpPr>
+        <p:cNvPr id="1" name=""/>
+        <p:cNvGrpSpPr/>
+        <p:nvPr/>
+      </p:nvGrpSpPr>
+      <p:grpSpPr/>
+      <p:pic>
+        <p:nvPicPr>
+          <p:cNvPr id="2" name="Picture 1" descr="slide-14.png"/>
+          <p:cNvPicPr>
+            <a:picLocks noChangeAspect="1"/>
+          </p:cNvPicPr>
           <p:nvPr/>
-        </p:nvSpPr>
+        </p:nvPicPr>
+        <p:blipFill>
+          <a:blip r:embed="rId2"/>
+          <a:stretch>
+            <a:fillRect/>
+          </a:stretch>
+        </p:blipFill>
         <p:spPr>
           <a:xfrm>
-            <a:off x="777240" y="6291072"/>
-            <a:ext cx="10637215" cy="320040"/>
+            <a:off x="0" y="0"/>
+            <a:ext cx="12191695" cy="6858000"/>
           </a:xfrm>
           <a:prstGeom prst="rect">
             <a:avLst/>
           </a:prstGeom>
-          <a:noFill/>
         </p:spPr>
-        <p:txBody>
-          <a:bodyPr wrap="square">
-            <a:spAutoFit/>
-          </a:bodyPr>
-          <a:lstStyle/>
-          <a:p>
-            <a:r>
-              <a:rPr sz="1000">
-                <a:solidFill>
-                  <a:srgbClr val="9CA3AF"/>
-                </a:solidFill>
-                <a:latin typeface="Calibri"/>
-              </a:rPr>
-              <a:t>Diya Meditation Kiosk  ·  Internship Report          10</a:t>
-            </a:r>
-          </a:p>
-        </p:txBody>
-      </p:sp>
+      </p:pic>
     </p:spTree>
   </p:cSld>
   <p:clrMapOvr>
@@ -5085,402 +4863,30 @@
         <p:nvPr/>
       </p:nvGrpSpPr>
       <p:grpSpPr/>
-      <p:sp>
-        <p:nvSpPr>
-          <p:cNvPr id="2" name="TextBox 1"/>
-          <p:cNvSpPr txBox="1"/>
+      <p:pic>
+        <p:nvPicPr>
+          <p:cNvPr id="2" name="Picture 1" descr="slide-02.png"/>
+          <p:cNvPicPr>
+            <a:picLocks noChangeAspect="1"/>
+          </p:cNvPicPr>
           <p:nvPr/>
-        </p:nvSpPr>
+        </p:nvPicPr>
+        <p:blipFill>
+          <a:blip r:embed="rId2"/>
+          <a:stretch>
+            <a:fillRect/>
+          </a:stretch>
+        </p:blipFill>
         <p:spPr>
           <a:xfrm>
-            <a:off x="777240" y="502920"/>
-            <a:ext cx="10637215" cy="274320"/>
+            <a:off x="0" y="0"/>
+            <a:ext cx="12191695" cy="6858000"/>
           </a:xfrm>
           <a:prstGeom prst="rect">
             <a:avLst/>
           </a:prstGeom>
-          <a:noFill/>
         </p:spPr>
-        <p:txBody>
-          <a:bodyPr wrap="square">
-            <a:spAutoFit/>
-          </a:bodyPr>
-          <a:lstStyle/>
-          <a:p>
-            <a:pPr algn="l">
-              <a:spcBef>
-                <a:spcPts val="0"/>
-              </a:spcBef>
-              <a:spcAft>
-                <a:spcPts val="0"/>
-              </a:spcAft>
-            </a:pPr>
-            <a:r>
-              <a:rPr sz="1100" b="1" i="0">
-                <a:solidFill>
-                  <a:srgbClr val="E9B872"/>
-                </a:solidFill>
-                <a:latin typeface="Calibri"/>
-              </a:rPr>
-              <a:t>CONTEXT</a:t>
-            </a:r>
-          </a:p>
-        </p:txBody>
-      </p:sp>
-      <p:sp>
-        <p:nvSpPr>
-          <p:cNvPr id="3" name="TextBox 2"/>
-          <p:cNvSpPr txBox="1"/>
-          <p:nvPr/>
-        </p:nvSpPr>
-        <p:spPr>
-          <a:xfrm>
-            <a:off x="777240" y="777240"/>
-            <a:ext cx="10637215" cy="640080"/>
-          </a:xfrm>
-          <a:prstGeom prst="rect">
-            <a:avLst/>
-          </a:prstGeom>
-          <a:noFill/>
-        </p:spPr>
-        <p:txBody>
-          <a:bodyPr wrap="square">
-            <a:spAutoFit/>
-          </a:bodyPr>
-          <a:lstStyle/>
-          <a:p>
-            <a:pPr algn="l">
-              <a:spcBef>
-                <a:spcPts val="0"/>
-              </a:spcBef>
-              <a:spcAft>
-                <a:spcPts val="0"/>
-              </a:spcAft>
-            </a:pPr>
-            <a:r>
-              <a:rPr sz="3000" b="1" i="0">
-                <a:solidFill>
-                  <a:srgbClr val="1A1330"/>
-                </a:solidFill>
-                <a:latin typeface="Calibri"/>
-              </a:rPr>
-              <a:t>The Problem, and What I Owned</a:t>
-            </a:r>
-          </a:p>
-        </p:txBody>
-      </p:sp>
-      <p:sp>
-        <p:nvSpPr>
-          <p:cNvPr id="4" name="Rectangle 3"/>
-          <p:cNvSpPr/>
-          <p:nvPr/>
-        </p:nvSpPr>
-        <p:spPr>
-          <a:xfrm>
-            <a:off x="777240" y="1481328"/>
-            <a:ext cx="1371600" cy="50800"/>
-          </a:xfrm>
-          <a:prstGeom prst="rect">
-            <a:avLst/>
-          </a:prstGeom>
-          <a:solidFill>
-            <a:srgbClr val="E9B872"/>
-          </a:solidFill>
-          <a:ln>
-            <a:noFill/>
-          </a:ln>
-          <a:effectLst/>
-        </p:spPr>
-        <p:style>
-          <a:lnRef idx="1">
-            <a:schemeClr val="accent1"/>
-          </a:lnRef>
-          <a:fillRef idx="3">
-            <a:schemeClr val="accent1"/>
-          </a:fillRef>
-          <a:effectRef idx="2">
-            <a:schemeClr val="accent1"/>
-          </a:effectRef>
-          <a:fontRef idx="minor">
-            <a:schemeClr val="lt1"/>
-          </a:fontRef>
-        </p:style>
-        <p:txBody>
-          <a:bodyPr rtlCol="0" anchor="ctr"/>
-          <a:lstStyle/>
-          <a:p>
-            <a:pPr algn="ctr"/>
-          </a:p>
-        </p:txBody>
-      </p:sp>
-      <p:sp>
-        <p:nvSpPr>
-          <p:cNvPr id="5" name="TextBox 4"/>
-          <p:cNvSpPr txBox="1"/>
-          <p:nvPr/>
-        </p:nvSpPr>
-        <p:spPr>
-          <a:xfrm>
-            <a:off x="777240" y="1783080"/>
-            <a:ext cx="10637215" cy="4389120"/>
-          </a:xfrm>
-          <a:prstGeom prst="rect">
-            <a:avLst/>
-          </a:prstGeom>
-          <a:noFill/>
-        </p:spPr>
-        <p:txBody>
-          <a:bodyPr wrap="square">
-            <a:spAutoFit/>
-          </a:bodyPr>
-          <a:lstStyle/>
-          <a:p>
-            <a:pPr algn="l">
-              <a:lnSpc>
-                <a:spcPct val="115000"/>
-              </a:lnSpc>
-              <a:spcBef>
-                <a:spcPts val="0"/>
-              </a:spcBef>
-              <a:spcAft>
-                <a:spcPts val="800"/>
-              </a:spcAft>
-            </a:pPr>
-            <a:r>
-              <a:rPr sz="1400" b="0" i="0">
-                <a:solidFill>
-                  <a:srgbClr val="374151"/>
-                </a:solidFill>
-                <a:latin typeface="Calibri"/>
-              </a:rPr>
-              <a:t>Build a kiosk for a public/museum setting that runs all day with nobody attending it.</a:t>
-            </a:r>
-          </a:p>
-          <a:p>
-            <a:pPr algn="l">
-              <a:spcBef>
-                <a:spcPts val="1000"/>
-              </a:spcBef>
-              <a:spcAft>
-                <a:spcPts val="400"/>
-              </a:spcAft>
-            </a:pPr>
-            <a:r>
-              <a:rPr sz="1500" b="1" i="0">
-                <a:solidFill>
-                  <a:srgbClr val="1A1330"/>
-                </a:solidFill>
-                <a:latin typeface="Calibri"/>
-              </a:rPr>
-              <a:t>It has to</a:t>
-            </a:r>
-          </a:p>
-          <a:p>
-            <a:pPr algn="l">
-              <a:lnSpc>
-                <a:spcPct val="115000"/>
-              </a:lnSpc>
-              <a:spcBef>
-                <a:spcPts val="0"/>
-              </a:spcBef>
-              <a:spcAft>
-                <a:spcPts val="700"/>
-              </a:spcAft>
-            </a:pPr>
-            <a:r>
-              <a:rPr sz="1500" b="0" i="0">
-                <a:solidFill>
-                  <a:srgbClr val="374151"/>
-                </a:solidFill>
-                <a:latin typeface="Calibri"/>
-              </a:rPr>
-              <a:t>•   Identify a visitor with no staff and no keyboard</a:t>
-            </a:r>
-          </a:p>
-          <a:p>
-            <a:pPr algn="l">
-              <a:lnSpc>
-                <a:spcPct val="115000"/>
-              </a:lnSpc>
-              <a:spcBef>
-                <a:spcPts val="0"/>
-              </a:spcBef>
-              <a:spcAft>
-                <a:spcPts val="700"/>
-              </a:spcAft>
-            </a:pPr>
-            <a:r>
-              <a:rPr sz="1500" b="0" i="0">
-                <a:solidFill>
-                  <a:srgbClr val="374151"/>
-                </a:solidFill>
-                <a:latin typeface="Calibri"/>
-              </a:rPr>
-              <a:t>•   Trigger a camera / computer-vision meditation session</a:t>
-            </a:r>
-          </a:p>
-          <a:p>
-            <a:pPr algn="l">
-              <a:lnSpc>
-                <a:spcPct val="115000"/>
-              </a:lnSpc>
-              <a:spcBef>
-                <a:spcPts val="0"/>
-              </a:spcBef>
-              <a:spcAft>
-                <a:spcPts val="700"/>
-              </a:spcAft>
-            </a:pPr>
-            <a:r>
-              <a:rPr sz="1500" b="0" i="0">
-                <a:solidFill>
-                  <a:srgbClr val="374151"/>
-                </a:solidFill>
-                <a:latin typeface="Calibri"/>
-              </a:rPr>
-              <a:t>•   Show that visitor their report, then reset for the next person</a:t>
-            </a:r>
-          </a:p>
-          <a:p>
-            <a:pPr algn="l">
-              <a:spcBef>
-                <a:spcPts val="1000"/>
-              </a:spcBef>
-              <a:spcAft>
-                <a:spcPts val="400"/>
-              </a:spcAft>
-            </a:pPr>
-            <a:r>
-              <a:rPr sz="1500" b="1" i="0">
-                <a:solidFill>
-                  <a:srgbClr val="1A1330"/>
-                </a:solidFill>
-                <a:latin typeface="Calibri"/>
-              </a:rPr>
-              <a:t>Two teams</a:t>
-            </a:r>
-          </a:p>
-          <a:p>
-            <a:pPr algn="l">
-              <a:lnSpc>
-                <a:spcPct val="115000"/>
-              </a:lnSpc>
-              <a:spcBef>
-                <a:spcPts val="0"/>
-              </a:spcBef>
-              <a:spcAft>
-                <a:spcPts val="700"/>
-              </a:spcAft>
-            </a:pPr>
-            <a:r>
-              <a:rPr sz="1500" b="0" i="0">
-                <a:solidFill>
-                  <a:srgbClr val="374151"/>
-                </a:solidFill>
-                <a:latin typeface="Calibri"/>
-              </a:rPr>
-              <a:t>•   Hardware / CV team (IITH) — cameras, servos, the meditation-app that produces the report PDF</a:t>
-            </a:r>
-          </a:p>
-          <a:p>
-            <a:pPr algn="l">
-              <a:lnSpc>
-                <a:spcPct val="115000"/>
-              </a:lnSpc>
-              <a:spcBef>
-                <a:spcPts val="0"/>
-              </a:spcBef>
-              <a:spcAft>
-                <a:spcPts val="700"/>
-              </a:spcAft>
-            </a:pPr>
-            <a:r>
-              <a:rPr sz="1500" b="0" i="0">
-                <a:solidFill>
-                  <a:srgbClr val="374151"/>
-                </a:solidFill>
-                <a:latin typeface="Calibri"/>
-              </a:rPr>
-              <a:t>•   Me — the desktop application, the identification system, the backend, packaging and deployment</a:t>
-            </a:r>
-          </a:p>
-          <a:p>
-            <a:pPr algn="l">
-              <a:spcBef>
-                <a:spcPts val="1000"/>
-              </a:spcBef>
-              <a:spcAft>
-                <a:spcPts val="400"/>
-              </a:spcAft>
-            </a:pPr>
-            <a:r>
-              <a:rPr sz="1500" b="1" i="0">
-                <a:solidFill>
-                  <a:srgbClr val="1A1330"/>
-                </a:solidFill>
-                <a:latin typeface="Calibri"/>
-              </a:rPr>
-              <a:t>The integration boundary I designed was deliberately thin</a:t>
-            </a:r>
-          </a:p>
-          <a:p>
-            <a:pPr algn="l">
-              <a:lnSpc>
-                <a:spcPct val="115000"/>
-              </a:lnSpc>
-              <a:spcBef>
-                <a:spcPts val="0"/>
-              </a:spcBef>
-              <a:spcAft>
-                <a:spcPts val="700"/>
-              </a:spcAft>
-            </a:pPr>
-            <a:r>
-              <a:rPr sz="1500" b="0" i="0">
-                <a:solidFill>
-                  <a:srgbClr val="374151"/>
-                </a:solidFill>
-                <a:latin typeface="Calibri"/>
-              </a:rPr>
-              <a:t>•   One bash script to launch, one directory to read the PDF back from</a:t>
-            </a:r>
-          </a:p>
-        </p:txBody>
-      </p:sp>
-      <p:sp>
-        <p:nvSpPr>
-          <p:cNvPr id="6" name="TextBox 5"/>
-          <p:cNvSpPr txBox="1"/>
-          <p:nvPr/>
-        </p:nvSpPr>
-        <p:spPr>
-          <a:xfrm>
-            <a:off x="777240" y="6291072"/>
-            <a:ext cx="10637215" cy="320040"/>
-          </a:xfrm>
-          <a:prstGeom prst="rect">
-            <a:avLst/>
-          </a:prstGeom>
-          <a:noFill/>
-        </p:spPr>
-        <p:txBody>
-          <a:bodyPr wrap="square">
-            <a:spAutoFit/>
-          </a:bodyPr>
-          <a:lstStyle/>
-          <a:p>
-            <a:r>
-              <a:rPr sz="1000">
-                <a:solidFill>
-                  <a:srgbClr val="9CA3AF"/>
-                </a:solidFill>
-                <a:latin typeface="Calibri"/>
-              </a:rPr>
-              <a:t>Diya Meditation Kiosk  ·  Internship Report          2</a:t>
-            </a:r>
-          </a:p>
-        </p:txBody>
-      </p:sp>
+      </p:pic>
     </p:spTree>
   </p:cSld>
   <p:clrMapOvr>
@@ -5499,399 +4905,30 @@
         <p:nvPr/>
       </p:nvGrpSpPr>
       <p:grpSpPr/>
-      <p:sp>
-        <p:nvSpPr>
-          <p:cNvPr id="2" name="TextBox 1"/>
-          <p:cNvSpPr txBox="1"/>
+      <p:pic>
+        <p:nvPicPr>
+          <p:cNvPr id="2" name="Picture 1" descr="slide-03.png"/>
+          <p:cNvPicPr>
+            <a:picLocks noChangeAspect="1"/>
+          </p:cNvPicPr>
           <p:nvPr/>
-        </p:nvSpPr>
+        </p:nvPicPr>
+        <p:blipFill>
+          <a:blip r:embed="rId2"/>
+          <a:stretch>
+            <a:fillRect/>
+          </a:stretch>
+        </p:blipFill>
         <p:spPr>
           <a:xfrm>
-            <a:off x="777240" y="502920"/>
-            <a:ext cx="10637215" cy="274320"/>
+            <a:off x="0" y="0"/>
+            <a:ext cx="12191695" cy="6858000"/>
           </a:xfrm>
           <a:prstGeom prst="rect">
             <a:avLst/>
           </a:prstGeom>
-          <a:noFill/>
         </p:spPr>
-        <p:txBody>
-          <a:bodyPr wrap="square">
-            <a:spAutoFit/>
-          </a:bodyPr>
-          <a:lstStyle/>
-          <a:p>
-            <a:pPr algn="l">
-              <a:spcBef>
-                <a:spcPts val="0"/>
-              </a:spcBef>
-              <a:spcAft>
-                <a:spcPts val="0"/>
-              </a:spcAft>
-            </a:pPr>
-            <a:r>
-              <a:rPr sz="1100" b="1" i="0">
-                <a:solidFill>
-                  <a:srgbClr val="E9B872"/>
-                </a:solidFill>
-                <a:latin typeface="Calibri"/>
-              </a:rPr>
-              <a:t>HOW IT FITS TOGETHER</a:t>
-            </a:r>
-          </a:p>
-        </p:txBody>
-      </p:sp>
-      <p:sp>
-        <p:nvSpPr>
-          <p:cNvPr id="3" name="TextBox 2"/>
-          <p:cNvSpPr txBox="1"/>
-          <p:nvPr/>
-        </p:nvSpPr>
-        <p:spPr>
-          <a:xfrm>
-            <a:off x="777240" y="777240"/>
-            <a:ext cx="10637215" cy="640080"/>
-          </a:xfrm>
-          <a:prstGeom prst="rect">
-            <a:avLst/>
-          </a:prstGeom>
-          <a:noFill/>
-        </p:spPr>
-        <p:txBody>
-          <a:bodyPr wrap="square">
-            <a:spAutoFit/>
-          </a:bodyPr>
-          <a:lstStyle/>
-          <a:p>
-            <a:pPr algn="l">
-              <a:spcBef>
-                <a:spcPts val="0"/>
-              </a:spcBef>
-              <a:spcAft>
-                <a:spcPts val="0"/>
-              </a:spcAft>
-            </a:pPr>
-            <a:r>
-              <a:rPr sz="3000" b="1" i="0">
-                <a:solidFill>
-                  <a:srgbClr val="1A1330"/>
-                </a:solidFill>
-                <a:latin typeface="Calibri"/>
-              </a:rPr>
-              <a:t>System Architecture</a:t>
-            </a:r>
-          </a:p>
-        </p:txBody>
-      </p:sp>
-      <p:sp>
-        <p:nvSpPr>
-          <p:cNvPr id="4" name="Rectangle 3"/>
-          <p:cNvSpPr/>
-          <p:nvPr/>
-        </p:nvSpPr>
-        <p:spPr>
-          <a:xfrm>
-            <a:off x="777240" y="1481328"/>
-            <a:ext cx="1371600" cy="50800"/>
-          </a:xfrm>
-          <a:prstGeom prst="rect">
-            <a:avLst/>
-          </a:prstGeom>
-          <a:solidFill>
-            <a:srgbClr val="E9B872"/>
-          </a:solidFill>
-          <a:ln>
-            <a:noFill/>
-          </a:ln>
-          <a:effectLst/>
-        </p:spPr>
-        <p:style>
-          <a:lnRef idx="1">
-            <a:schemeClr val="accent1"/>
-          </a:lnRef>
-          <a:fillRef idx="3">
-            <a:schemeClr val="accent1"/>
-          </a:fillRef>
-          <a:effectRef idx="2">
-            <a:schemeClr val="accent1"/>
-          </a:effectRef>
-          <a:fontRef idx="minor">
-            <a:schemeClr val="lt1"/>
-          </a:fontRef>
-        </p:style>
-        <p:txBody>
-          <a:bodyPr rtlCol="0" anchor="ctr"/>
-          <a:lstStyle/>
-          <a:p>
-            <a:pPr algn="ctr"/>
-          </a:p>
-        </p:txBody>
-      </p:sp>
-      <p:sp>
-        <p:nvSpPr>
-          <p:cNvPr id="5" name="TextBox 4"/>
-          <p:cNvSpPr txBox="1"/>
-          <p:nvPr/>
-        </p:nvSpPr>
-        <p:spPr>
-          <a:xfrm>
-            <a:off x="777240" y="1783080"/>
-            <a:ext cx="10637215" cy="4389120"/>
-          </a:xfrm>
-          <a:prstGeom prst="rect">
-            <a:avLst/>
-          </a:prstGeom>
-          <a:noFill/>
-        </p:spPr>
-        <p:txBody>
-          <a:bodyPr wrap="square">
-            <a:spAutoFit/>
-          </a:bodyPr>
-          <a:lstStyle/>
-          <a:p>
-            <a:pPr algn="l">
-              <a:spcBef>
-                <a:spcPts val="0"/>
-              </a:spcBef>
-              <a:spcAft>
-                <a:spcPts val="400"/>
-              </a:spcAft>
-            </a:pPr>
-            <a:r>
-              <a:rPr sz="1500" b="1" i="0">
-                <a:solidFill>
-                  <a:srgbClr val="1A1330"/>
-                </a:solidFill>
-                <a:latin typeface="Calibri"/>
-              </a:rPr>
-              <a:t>1 · Kiosk application    DiyaMeditation/</a:t>
-            </a:r>
-          </a:p>
-          <a:p>
-            <a:pPr algn="l">
-              <a:lnSpc>
-                <a:spcPct val="115000"/>
-              </a:lnSpc>
-              <a:spcBef>
-                <a:spcPts val="0"/>
-              </a:spcBef>
-              <a:spcAft>
-                <a:spcPts val="700"/>
-              </a:spcAft>
-            </a:pPr>
-            <a:r>
-              <a:rPr sz="1500" b="0" i="0">
-                <a:solidFill>
-                  <a:srgbClr val="374151"/>
-                </a:solidFill>
-                <a:latin typeface="Calibri"/>
-              </a:rPr>
-              <a:t>•   C# / .NET 8 LTS + Avalonia 11.2.3 — the cross-platform UI framework that officially supports Linux</a:t>
-            </a:r>
-          </a:p>
-          <a:p>
-            <a:pPr algn="l">
-              <a:lnSpc>
-                <a:spcPct val="115000"/>
-              </a:lnSpc>
-              <a:spcBef>
-                <a:spcPts val="0"/>
-              </a:spcBef>
-              <a:spcAft>
-                <a:spcPts val="700"/>
-              </a:spcAft>
-            </a:pPr>
-            <a:r>
-              <a:rPr sz="1500" b="0" i="0">
-                <a:solidFill>
-                  <a:srgbClr val="374151"/>
-                </a:solidFill>
-                <a:latin typeface="Calibri"/>
-              </a:rPr>
-              <a:t>•   Ships as a self-contained single-file .deb (amd64 + arm64) — target needs no .NET installed</a:t>
-            </a:r>
-          </a:p>
-          <a:p>
-            <a:pPr algn="l">
-              <a:spcBef>
-                <a:spcPts val="1000"/>
-              </a:spcBef>
-              <a:spcAft>
-                <a:spcPts val="400"/>
-              </a:spcAft>
-            </a:pPr>
-            <a:r>
-              <a:rPr sz="1500" b="1" i="0">
-                <a:solidFill>
-                  <a:srgbClr val="1A1330"/>
-                </a:solidFill>
-                <a:latin typeface="Calibri"/>
-              </a:rPr>
-              <a:t>2 · Backend    server/</a:t>
-            </a:r>
-          </a:p>
-          <a:p>
-            <a:pPr algn="l">
-              <a:lnSpc>
-                <a:spcPct val="115000"/>
-              </a:lnSpc>
-              <a:spcBef>
-                <a:spcPts val="0"/>
-              </a:spcBef>
-              <a:spcAft>
-                <a:spcPts val="700"/>
-              </a:spcAft>
-            </a:pPr>
-            <a:r>
-              <a:rPr sz="1500" b="0" i="0">
-                <a:solidFill>
-                  <a:srgbClr val="374151"/>
-                </a:solidFill>
-                <a:latin typeface="Calibri"/>
-              </a:rPr>
-              <a:t>•   Node + Express + Postgres, hosted on Render; also serves the static pages</a:t>
-            </a:r>
-          </a:p>
-          <a:p>
-            <a:pPr algn="l">
-              <a:lnSpc>
-                <a:spcPct val="115000"/>
-              </a:lnSpc>
-              <a:spcBef>
-                <a:spcPts val="0"/>
-              </a:spcBef>
-              <a:spcAft>
-                <a:spcPts val="700"/>
-              </a:spcAft>
-            </a:pPr>
-            <a:r>
-              <a:rPr sz="1500" b="0" i="0">
-                <a:solidFill>
-                  <a:srgbClr val="374151"/>
-                </a:solidFill>
-                <a:latin typeface="Calibri"/>
-              </a:rPr>
-              <a:t>•   Three tables: visitors, sessions, people (the admin roster)</a:t>
-            </a:r>
-          </a:p>
-          <a:p>
-            <a:pPr algn="l">
-              <a:spcBef>
-                <a:spcPts val="1000"/>
-              </a:spcBef>
-              <a:spcAft>
-                <a:spcPts val="400"/>
-              </a:spcAft>
-            </a:pPr>
-            <a:r>
-              <a:rPr sz="1500" b="1" i="0">
-                <a:solidFill>
-                  <a:srgbClr val="1A1330"/>
-                </a:solidFill>
-                <a:latin typeface="Calibri"/>
-              </a:rPr>
-              <a:t>3 · Web pages    registration/</a:t>
-            </a:r>
-          </a:p>
-          <a:p>
-            <a:pPr algn="l">
-              <a:lnSpc>
-                <a:spcPct val="115000"/>
-              </a:lnSpc>
-              <a:spcBef>
-                <a:spcPts val="0"/>
-              </a:spcBef>
-              <a:spcAft>
-                <a:spcPts val="700"/>
-              </a:spcAft>
-            </a:pPr>
-            <a:r>
-              <a:rPr sz="1500" b="0" i="0">
-                <a:solidFill>
-                  <a:srgbClr val="374151"/>
-                </a:solidFill>
-                <a:latin typeface="Calibri"/>
-              </a:rPr>
-              <a:t>•   Visitor self-registration, admin roster upload, and the per-person phone login + scanner</a:t>
-            </a:r>
-          </a:p>
-          <a:p>
-            <a:pPr algn="l">
-              <a:spcBef>
-                <a:spcPts val="1000"/>
-              </a:spcBef>
-              <a:spcAft>
-                <a:spcPts val="400"/>
-              </a:spcAft>
-            </a:pPr>
-            <a:r>
-              <a:rPr sz="1500" b="1" i="0">
-                <a:solidFill>
-                  <a:srgbClr val="1A1330"/>
-                </a:solidFill>
-                <a:latin typeface="Calibri"/>
-              </a:rPr>
-              <a:t>External, from the hardware team</a:t>
-            </a:r>
-          </a:p>
-          <a:p>
-            <a:pPr algn="l">
-              <a:lnSpc>
-                <a:spcPct val="115000"/>
-              </a:lnSpc>
-              <a:spcBef>
-                <a:spcPts val="0"/>
-              </a:spcBef>
-              <a:spcAft>
-                <a:spcPts val="700"/>
-              </a:spcAft>
-            </a:pPr>
-            <a:r>
-              <a:rPr sz="1500" b="0" i="0">
-                <a:solidFill>
-                  <a:srgbClr val="374151"/>
-                </a:solidFill>
-                <a:latin typeface="Calibri"/>
-              </a:rPr>
-              <a:t>•   Python CV scripts + meditation-app, which writes the report PDF the kiosk renders</a:t>
-            </a:r>
-          </a:p>
-        </p:txBody>
-      </p:sp>
-      <p:sp>
-        <p:nvSpPr>
-          <p:cNvPr id="6" name="TextBox 5"/>
-          <p:cNvSpPr txBox="1"/>
-          <p:nvPr/>
-        </p:nvSpPr>
-        <p:spPr>
-          <a:xfrm>
-            <a:off x="777240" y="6291072"/>
-            <a:ext cx="10637215" cy="320040"/>
-          </a:xfrm>
-          <a:prstGeom prst="rect">
-            <a:avLst/>
-          </a:prstGeom>
-          <a:noFill/>
-        </p:spPr>
-        <p:txBody>
-          <a:bodyPr wrap="square">
-            <a:spAutoFit/>
-          </a:bodyPr>
-          <a:lstStyle/>
-          <a:p>
-            <a:r>
-              <a:rPr sz="1000">
-                <a:solidFill>
-                  <a:srgbClr val="9CA3AF"/>
-                </a:solidFill>
-                <a:latin typeface="Calibri"/>
-              </a:rPr>
-              <a:t>Diya Meditation Kiosk  ·  Internship Report          3</a:t>
-            </a:r>
-          </a:p>
-        </p:txBody>
-      </p:sp>
+      </p:pic>
     </p:spTree>
   </p:cSld>
   <p:clrMapOvr>
@@ -5910,358 +4947,30 @@
         <p:nvPr/>
       </p:nvGrpSpPr>
       <p:grpSpPr/>
-      <p:sp>
-        <p:nvSpPr>
-          <p:cNvPr id="2" name="TextBox 1"/>
-          <p:cNvSpPr txBox="1"/>
+      <p:pic>
+        <p:nvPicPr>
+          <p:cNvPr id="2" name="Picture 1" descr="slide-04.png"/>
+          <p:cNvPicPr>
+            <a:picLocks noChangeAspect="1"/>
+          </p:cNvPicPr>
           <p:nvPr/>
-        </p:nvSpPr>
+        </p:nvPicPr>
+        <p:blipFill>
+          <a:blip r:embed="rId2"/>
+          <a:stretch>
+            <a:fillRect/>
+          </a:stretch>
+        </p:blipFill>
         <p:spPr>
           <a:xfrm>
-            <a:off x="777240" y="502920"/>
-            <a:ext cx="10637215" cy="274320"/>
+            <a:off x="0" y="0"/>
+            <a:ext cx="12191695" cy="6858000"/>
           </a:xfrm>
           <a:prstGeom prst="rect">
             <a:avLst/>
           </a:prstGeom>
-          <a:noFill/>
         </p:spPr>
-        <p:txBody>
-          <a:bodyPr wrap="square">
-            <a:spAutoFit/>
-          </a:bodyPr>
-          <a:lstStyle/>
-          <a:p>
-            <a:pPr algn="l">
-              <a:spcBef>
-                <a:spcPts val="0"/>
-              </a:spcBef>
-              <a:spcAft>
-                <a:spcPts val="0"/>
-              </a:spcAft>
-            </a:pPr>
-            <a:r>
-              <a:rPr sz="1100" b="1" i="0">
-                <a:solidFill>
-                  <a:srgbClr val="E9B872"/>
-                </a:solidFill>
-                <a:latin typeface="Calibri"/>
-              </a:rPr>
-              <a:t>DESIGN</a:t>
-            </a:r>
-          </a:p>
-        </p:txBody>
-      </p:sp>
-      <p:sp>
-        <p:nvSpPr>
-          <p:cNvPr id="3" name="TextBox 2"/>
-          <p:cNvSpPr txBox="1"/>
-          <p:nvPr/>
-        </p:nvSpPr>
-        <p:spPr>
-          <a:xfrm>
-            <a:off x="777240" y="777240"/>
-            <a:ext cx="10637215" cy="640080"/>
-          </a:xfrm>
-          <a:prstGeom prst="rect">
-            <a:avLst/>
-          </a:prstGeom>
-          <a:noFill/>
-        </p:spPr>
-        <p:txBody>
-          <a:bodyPr wrap="square">
-            <a:spAutoFit/>
-          </a:bodyPr>
-          <a:lstStyle/>
-          <a:p>
-            <a:pPr algn="l">
-              <a:spcBef>
-                <a:spcPts val="0"/>
-              </a:spcBef>
-              <a:spcAft>
-                <a:spcPts val="0"/>
-              </a:spcAft>
-            </a:pPr>
-            <a:r>
-              <a:rPr sz="3000" b="1" i="0">
-                <a:solidFill>
-                  <a:srgbClr val="1A1330"/>
-                </a:solidFill>
-                <a:latin typeface="Calibri"/>
-              </a:rPr>
-              <a:t>The Decision That Mattered Most: Invert the QR</a:t>
-            </a:r>
-          </a:p>
-        </p:txBody>
-      </p:sp>
-      <p:sp>
-        <p:nvSpPr>
-          <p:cNvPr id="4" name="Rectangle 3"/>
-          <p:cNvSpPr/>
-          <p:nvPr/>
-        </p:nvSpPr>
-        <p:spPr>
-          <a:xfrm>
-            <a:off x="777240" y="1481328"/>
-            <a:ext cx="1371600" cy="50800"/>
-          </a:xfrm>
-          <a:prstGeom prst="rect">
-            <a:avLst/>
-          </a:prstGeom>
-          <a:solidFill>
-            <a:srgbClr val="E9B872"/>
-          </a:solidFill>
-          <a:ln>
-            <a:noFill/>
-          </a:ln>
-          <a:effectLst/>
-        </p:spPr>
-        <p:style>
-          <a:lnRef idx="1">
-            <a:schemeClr val="accent1"/>
-          </a:lnRef>
-          <a:fillRef idx="3">
-            <a:schemeClr val="accent1"/>
-          </a:fillRef>
-          <a:effectRef idx="2">
-            <a:schemeClr val="accent1"/>
-          </a:effectRef>
-          <a:fontRef idx="minor">
-            <a:schemeClr val="lt1"/>
-          </a:fontRef>
-        </p:style>
-        <p:txBody>
-          <a:bodyPr rtlCol="0" anchor="ctr"/>
-          <a:lstStyle/>
-          <a:p>
-            <a:pPr algn="ctr"/>
-          </a:p>
-        </p:txBody>
-      </p:sp>
-      <p:sp>
-        <p:nvSpPr>
-          <p:cNvPr id="5" name="TextBox 4"/>
-          <p:cNvSpPr txBox="1"/>
-          <p:nvPr/>
-        </p:nvSpPr>
-        <p:spPr>
-          <a:xfrm>
-            <a:off x="777240" y="1783080"/>
-            <a:ext cx="10637215" cy="4389120"/>
-          </a:xfrm>
-          <a:prstGeom prst="rect">
-            <a:avLst/>
-          </a:prstGeom>
-          <a:noFill/>
-        </p:spPr>
-        <p:txBody>
-          <a:bodyPr wrap="square">
-            <a:spAutoFit/>
-          </a:bodyPr>
-          <a:lstStyle/>
-          <a:p>
-            <a:pPr algn="l">
-              <a:lnSpc>
-                <a:spcPct val="115000"/>
-              </a:lnSpc>
-              <a:spcBef>
-                <a:spcPts val="0"/>
-              </a:spcBef>
-              <a:spcAft>
-                <a:spcPts val="800"/>
-              </a:spcAft>
-            </a:pPr>
-            <a:r>
-              <a:rPr sz="1400" b="0" i="0">
-                <a:solidFill>
-                  <a:srgbClr val="374151"/>
-                </a:solidFill>
-                <a:latin typeface="Calibri"/>
-              </a:rPr>
-              <a:t>Identifying someone at an unattended kiosk normally means buying scanner hardware. I went through three designs before finding the one that needed none.</a:t>
-            </a:r>
-          </a:p>
-          <a:p>
-            <a:pPr algn="l">
-              <a:spcBef>
-                <a:spcPts val="1000"/>
-              </a:spcBef>
-              <a:spcAft>
-                <a:spcPts val="400"/>
-              </a:spcAft>
-            </a:pPr>
-            <a:r>
-              <a:rPr sz="1500" b="1" i="0">
-                <a:solidFill>
-                  <a:srgbClr val="1A1330"/>
-                </a:solidFill>
-                <a:latin typeface="Calibri"/>
-              </a:rPr>
-              <a:t>Attempt 1 — put the visitor's data inside the QR</a:t>
-            </a:r>
-          </a:p>
-          <a:p>
-            <a:pPr algn="l">
-              <a:lnSpc>
-                <a:spcPct val="115000"/>
-              </a:lnSpc>
-              <a:spcBef>
-                <a:spcPts val="0"/>
-              </a:spcBef>
-              <a:spcAft>
-                <a:spcPts val="700"/>
-              </a:spcAft>
-            </a:pPr>
-            <a:r>
-              <a:rPr sz="1500" b="0" i="0">
-                <a:solidFill>
-                  <a:srgbClr val="374151"/>
-                </a:solidFill>
-                <a:latin typeface="Calibri"/>
-              </a:rPr>
-              <a:t>•   Fully offline, but still needs a scanner at the kiosk, and puts personal data in a printed code</a:t>
-            </a:r>
-          </a:p>
-          <a:p>
-            <a:pPr algn="l">
-              <a:spcBef>
-                <a:spcPts val="1000"/>
-              </a:spcBef>
-              <a:spcAft>
-                <a:spcPts val="400"/>
-              </a:spcAft>
-            </a:pPr>
-            <a:r>
-              <a:rPr sz="1500" b="1" i="0">
-                <a:solidFill>
-                  <a:srgbClr val="1A1330"/>
-                </a:solidFill>
-                <a:latin typeface="Calibri"/>
-              </a:rPr>
-              <a:t>Attempt 2 — QR holds only an id, the kiosk looks it up over the API</a:t>
-            </a:r>
-          </a:p>
-          <a:p>
-            <a:pPr algn="l">
-              <a:lnSpc>
-                <a:spcPct val="115000"/>
-              </a:lnSpc>
-              <a:spcBef>
-                <a:spcPts val="0"/>
-              </a:spcBef>
-              <a:spcAft>
-                <a:spcPts val="700"/>
-              </a:spcAft>
-            </a:pPr>
-            <a:r>
-              <a:rPr sz="1500" b="0" i="0">
-                <a:solidFill>
-                  <a:srgbClr val="374151"/>
-                </a:solidFill>
-                <a:latin typeface="Calibri"/>
-              </a:rPr>
-              <a:t>•   No data in the code — but the kiosk still needs a scanner</a:t>
-            </a:r>
-          </a:p>
-          <a:p>
-            <a:pPr algn="l">
-              <a:spcBef>
-                <a:spcPts val="1000"/>
-              </a:spcBef>
-              <a:spcAft>
-                <a:spcPts val="400"/>
-              </a:spcAft>
-            </a:pPr>
-            <a:r>
-              <a:rPr sz="1500" b="1" i="0">
-                <a:solidFill>
-                  <a:srgbClr val="1A1330"/>
-                </a:solidFill>
-                <a:latin typeface="Calibri"/>
-              </a:rPr>
-              <a:t>Final — the kiosk shows the QR, and the visitor's phone scans it</a:t>
-            </a:r>
-          </a:p>
-          <a:p>
-            <a:pPr algn="l">
-              <a:lnSpc>
-                <a:spcPct val="115000"/>
-              </a:lnSpc>
-              <a:spcBef>
-                <a:spcPts val="0"/>
-              </a:spcBef>
-              <a:spcAft>
-                <a:spcPts val="700"/>
-              </a:spcAft>
-            </a:pPr>
-            <a:r>
-              <a:rPr sz="1500" b="0" i="0">
-                <a:solidFill>
-                  <a:srgbClr val="374151"/>
-                </a:solidFill>
-                <a:latin typeface="Calibri"/>
-              </a:rPr>
-              <a:t>•   The phone becomes the scanner, the camera and the keyboard. Zero hardware at the kiosk.</a:t>
-            </a:r>
-          </a:p>
-          <a:p>
-            <a:pPr algn="l">
-              <a:lnSpc>
-                <a:spcPct val="115000"/>
-              </a:lnSpc>
-              <a:spcBef>
-                <a:spcPts val="0"/>
-              </a:spcBef>
-              <a:spcAft>
-                <a:spcPts val="700"/>
-              </a:spcAft>
-            </a:pPr>
-            <a:r>
-              <a:rPr sz="1500" b="0" i="0">
-                <a:solidFill>
-                  <a:srgbClr val="374151"/>
-                </a:solidFill>
-                <a:latin typeface="Calibri"/>
-              </a:rPr>
-              <a:t>•   Kiosk creates a session → displays it as a QR → phone claims it → kiosk polls and auto-advances</a:t>
-            </a:r>
-          </a:p>
-        </p:txBody>
-      </p:sp>
-      <p:sp>
-        <p:nvSpPr>
-          <p:cNvPr id="6" name="TextBox 5"/>
-          <p:cNvSpPr txBox="1"/>
-          <p:nvPr/>
-        </p:nvSpPr>
-        <p:spPr>
-          <a:xfrm>
-            <a:off x="777240" y="6291072"/>
-            <a:ext cx="10637215" cy="320040"/>
-          </a:xfrm>
-          <a:prstGeom prst="rect">
-            <a:avLst/>
-          </a:prstGeom>
-          <a:noFill/>
-        </p:spPr>
-        <p:txBody>
-          <a:bodyPr wrap="square">
-            <a:spAutoFit/>
-          </a:bodyPr>
-          <a:lstStyle/>
-          <a:p>
-            <a:r>
-              <a:rPr sz="1000">
-                <a:solidFill>
-                  <a:srgbClr val="9CA3AF"/>
-                </a:solidFill>
-                <a:latin typeface="Calibri"/>
-              </a:rPr>
-              <a:t>Diya Meditation Kiosk  ·  Internship Report          4</a:t>
-            </a:r>
-          </a:p>
-        </p:txBody>
-      </p:sp>
+      </p:pic>
     </p:spTree>
   </p:cSld>
   <p:clrMapOvr>
@@ -6280,402 +4989,30 @@
         <p:nvPr/>
       </p:nvGrpSpPr>
       <p:grpSpPr/>
-      <p:sp>
-        <p:nvSpPr>
-          <p:cNvPr id="2" name="TextBox 1"/>
-          <p:cNvSpPr txBox="1"/>
+      <p:pic>
+        <p:nvPicPr>
+          <p:cNvPr id="2" name="Picture 1" descr="slide-05.png"/>
+          <p:cNvPicPr>
+            <a:picLocks noChangeAspect="1"/>
+          </p:cNvPicPr>
           <p:nvPr/>
-        </p:nvSpPr>
+        </p:nvPicPr>
+        <p:blipFill>
+          <a:blip r:embed="rId2"/>
+          <a:stretch>
+            <a:fillRect/>
+          </a:stretch>
+        </p:blipFill>
         <p:spPr>
           <a:xfrm>
-            <a:off x="777240" y="502920"/>
-            <a:ext cx="10637215" cy="274320"/>
+            <a:off x="0" y="0"/>
+            <a:ext cx="12191695" cy="6858000"/>
           </a:xfrm>
           <a:prstGeom prst="rect">
             <a:avLst/>
           </a:prstGeom>
-          <a:noFill/>
         </p:spPr>
-        <p:txBody>
-          <a:bodyPr wrap="square">
-            <a:spAutoFit/>
-          </a:bodyPr>
-          <a:lstStyle/>
-          <a:p>
-            <a:pPr algn="l">
-              <a:spcBef>
-                <a:spcPts val="0"/>
-              </a:spcBef>
-              <a:spcAft>
-                <a:spcPts val="0"/>
-              </a:spcAft>
-            </a:pPr>
-            <a:r>
-              <a:rPr sz="1100" b="1" i="0">
-                <a:solidFill>
-                  <a:srgbClr val="E9B872"/>
-                </a:solidFill>
-                <a:latin typeface="Calibri"/>
-              </a:rPr>
-              <a:t>THE FLOW END TO END</a:t>
-            </a:r>
-          </a:p>
-        </p:txBody>
-      </p:sp>
-      <p:sp>
-        <p:nvSpPr>
-          <p:cNvPr id="3" name="TextBox 2"/>
-          <p:cNvSpPr txBox="1"/>
-          <p:nvPr/>
-        </p:nvSpPr>
-        <p:spPr>
-          <a:xfrm>
-            <a:off x="777240" y="777240"/>
-            <a:ext cx="10637215" cy="640080"/>
-          </a:xfrm>
-          <a:prstGeom prst="rect">
-            <a:avLst/>
-          </a:prstGeom>
-          <a:noFill/>
-        </p:spPr>
-        <p:txBody>
-          <a:bodyPr wrap="square">
-            <a:spAutoFit/>
-          </a:bodyPr>
-          <a:lstStyle/>
-          <a:p>
-            <a:pPr algn="l">
-              <a:spcBef>
-                <a:spcPts val="0"/>
-              </a:spcBef>
-              <a:spcAft>
-                <a:spcPts val="0"/>
-              </a:spcAft>
-            </a:pPr>
-            <a:r>
-              <a:rPr sz="3000" b="1" i="0">
-                <a:solidFill>
-                  <a:srgbClr val="1A1330"/>
-                </a:solidFill>
-                <a:latin typeface="Calibri"/>
-              </a:rPr>
-              <a:t>How a Visitor Actually Logs In</a:t>
-            </a:r>
-          </a:p>
-        </p:txBody>
-      </p:sp>
-      <p:sp>
-        <p:nvSpPr>
-          <p:cNvPr id="4" name="Rectangle 3"/>
-          <p:cNvSpPr/>
-          <p:nvPr/>
-        </p:nvSpPr>
-        <p:spPr>
-          <a:xfrm>
-            <a:off x="777240" y="1481328"/>
-            <a:ext cx="1371600" cy="50800"/>
-          </a:xfrm>
-          <a:prstGeom prst="rect">
-            <a:avLst/>
-          </a:prstGeom>
-          <a:solidFill>
-            <a:srgbClr val="E9B872"/>
-          </a:solidFill>
-          <a:ln>
-            <a:noFill/>
-          </a:ln>
-          <a:effectLst/>
-        </p:spPr>
-        <p:style>
-          <a:lnRef idx="1">
-            <a:schemeClr val="accent1"/>
-          </a:lnRef>
-          <a:fillRef idx="3">
-            <a:schemeClr val="accent1"/>
-          </a:fillRef>
-          <a:effectRef idx="2">
-            <a:schemeClr val="accent1"/>
-          </a:effectRef>
-          <a:fontRef idx="minor">
-            <a:schemeClr val="lt1"/>
-          </a:fontRef>
-        </p:style>
-        <p:txBody>
-          <a:bodyPr rtlCol="0" anchor="ctr"/>
-          <a:lstStyle/>
-          <a:p>
-            <a:pPr algn="ctr"/>
-          </a:p>
-        </p:txBody>
-      </p:sp>
-      <p:sp>
-        <p:nvSpPr>
-          <p:cNvPr id="5" name="TextBox 4"/>
-          <p:cNvSpPr txBox="1"/>
-          <p:nvPr/>
-        </p:nvSpPr>
-        <p:spPr>
-          <a:xfrm>
-            <a:off x="777240" y="1783080"/>
-            <a:ext cx="10637215" cy="4389120"/>
-          </a:xfrm>
-          <a:prstGeom prst="rect">
-            <a:avLst/>
-          </a:prstGeom>
-          <a:noFill/>
-        </p:spPr>
-        <p:txBody>
-          <a:bodyPr wrap="square">
-            <a:spAutoFit/>
-          </a:bodyPr>
-          <a:lstStyle/>
-          <a:p>
-            <a:pPr algn="l">
-              <a:spcBef>
-                <a:spcPts val="0"/>
-              </a:spcBef>
-              <a:spcAft>
-                <a:spcPts val="400"/>
-              </a:spcAft>
-            </a:pPr>
-            <a:r>
-              <a:rPr sz="1500" b="1" i="0">
-                <a:solidFill>
-                  <a:srgbClr val="1A1330"/>
-                </a:solidFill>
-                <a:latin typeface="Calibri"/>
-              </a:rPr>
-              <a:t>Before the event</a:t>
-            </a:r>
-          </a:p>
-          <a:p>
-            <a:pPr algn="l">
-              <a:lnSpc>
-                <a:spcPct val="115000"/>
-              </a:lnSpc>
-              <a:spcBef>
-                <a:spcPts val="0"/>
-              </a:spcBef>
-              <a:spcAft>
-                <a:spcPts val="700"/>
-              </a:spcAft>
-            </a:pPr>
-            <a:r>
-              <a:rPr sz="1500" b="0" i="0">
-                <a:solidFill>
-                  <a:srgbClr val="374151"/>
-                </a:solidFill>
-                <a:latin typeface="Calibri"/>
-              </a:rPr>
-              <a:t>•   An admin uploads an XLSX roster at /admin (protected by an ADMIN_KEY on the server)</a:t>
-            </a:r>
-          </a:p>
-          <a:p>
-            <a:pPr algn="l">
-              <a:lnSpc>
-                <a:spcPct val="115000"/>
-              </a:lnSpc>
-              <a:spcBef>
-                <a:spcPts val="0"/>
-              </a:spcBef>
-              <a:spcAft>
-                <a:spcPts val="700"/>
-              </a:spcAft>
-            </a:pPr>
-            <a:r>
-              <a:rPr sz="1500" b="0" i="0">
-                <a:solidFill>
-                  <a:srgbClr val="374151"/>
-                </a:solidFill>
-                <a:latin typeface="Calibri"/>
-              </a:rPr>
-              <a:t>•   The sheet is parsed in the browser; every person gets an unguessable personal link, /p/&lt;token&gt;</a:t>
-            </a:r>
-          </a:p>
-          <a:p>
-            <a:pPr algn="l">
-              <a:lnSpc>
-                <a:spcPct val="115000"/>
-              </a:lnSpc>
-              <a:spcBef>
-                <a:spcPts val="0"/>
-              </a:spcBef>
-              <a:spcAft>
-                <a:spcPts val="700"/>
-              </a:spcAft>
-            </a:pPr>
-            <a:r>
-              <a:rPr sz="1500" b="0" i="0">
-                <a:solidFill>
-                  <a:srgbClr val="374151"/>
-                </a:solidFill>
-                <a:latin typeface="Calibri"/>
-              </a:rPr>
-              <a:t>•   Column headers are matched loosely, so real-world sheets like “Image Link (Gdrive …)” still map</a:t>
-            </a:r>
-          </a:p>
-          <a:p>
-            <a:pPr algn="l">
-              <a:spcBef>
-                <a:spcPts val="1000"/>
-              </a:spcBef>
-              <a:spcAft>
-                <a:spcPts val="400"/>
-              </a:spcAft>
-            </a:pPr>
-            <a:r>
-              <a:rPr sz="1500" b="1" i="0">
-                <a:solidFill>
-                  <a:srgbClr val="1A1330"/>
-                </a:solidFill>
-                <a:latin typeface="Calibri"/>
-              </a:rPr>
-              <a:t>At the kiosk</a:t>
-            </a:r>
-          </a:p>
-          <a:p>
-            <a:pPr algn="l">
-              <a:lnSpc>
-                <a:spcPct val="115000"/>
-              </a:lnSpc>
-              <a:spcBef>
-                <a:spcPts val="0"/>
-              </a:spcBef>
-              <a:spcAft>
-                <a:spcPts val="700"/>
-              </a:spcAft>
-            </a:pPr>
-            <a:r>
-              <a:rPr sz="1500" b="0" i="0">
-                <a:solidFill>
-                  <a:srgbClr val="374151"/>
-                </a:solidFill>
-                <a:latin typeface="Calibri"/>
-              </a:rPr>
-              <a:t>•   The person opens their link on their phone and is greeted by name</a:t>
-            </a:r>
-          </a:p>
-          <a:p>
-            <a:pPr algn="l">
-              <a:lnSpc>
-                <a:spcPct val="115000"/>
-              </a:lnSpc>
-              <a:spcBef>
-                <a:spcPts val="0"/>
-              </a:spcBef>
-              <a:spcAft>
-                <a:spcPts val="700"/>
-              </a:spcAft>
-            </a:pPr>
-            <a:r>
-              <a:rPr sz="1500" b="0" i="0">
-                <a:solidFill>
-                  <a:srgbClr val="374151"/>
-                </a:solidFill>
-                <a:latin typeface="Calibri"/>
-              </a:rPr>
-              <a:t>•   “Proceed” opens the phone camera; they scan the QR on the kiosk screen</a:t>
-            </a:r>
-          </a:p>
-          <a:p>
-            <a:pPr algn="l">
-              <a:lnSpc>
-                <a:spcPct val="115000"/>
-              </a:lnSpc>
-              <a:spcBef>
-                <a:spcPts val="0"/>
-              </a:spcBef>
-              <a:spcAft>
-                <a:spcPts val="700"/>
-              </a:spcAft>
-            </a:pPr>
-            <a:r>
-              <a:rPr sz="1500" b="0" i="0">
-                <a:solidFill>
-                  <a:srgbClr val="374151"/>
-                </a:solidFill>
-                <a:latin typeface="Calibri"/>
-              </a:rPr>
-              <a:t>•   The kiosk shows their name and photo, then starts the session automatically — no button press</a:t>
-            </a:r>
-          </a:p>
-          <a:p>
-            <a:pPr algn="l">
-              <a:spcBef>
-                <a:spcPts val="1000"/>
-              </a:spcBef>
-              <a:spcAft>
-                <a:spcPts val="400"/>
-              </a:spcAft>
-            </a:pPr>
-            <a:r>
-              <a:rPr sz="1500" b="1" i="0">
-                <a:solidFill>
-                  <a:srgbClr val="1A1330"/>
-                </a:solidFill>
-                <a:latin typeface="Calibri"/>
-              </a:rPr>
-              <a:t>Privacy handling</a:t>
-            </a:r>
-          </a:p>
-          <a:p>
-            <a:pPr algn="l">
-              <a:lnSpc>
-                <a:spcPct val="115000"/>
-              </a:lnSpc>
-              <a:spcBef>
-                <a:spcPts val="0"/>
-              </a:spcBef>
-              <a:spcAft>
-                <a:spcPts val="700"/>
-              </a:spcAft>
-            </a:pPr>
-            <a:r>
-              <a:rPr sz="1500" b="0" i="0">
-                <a:solidFill>
-                  <a:srgbClr val="374151"/>
-                </a:solidFill>
-                <a:latin typeface="Calibri"/>
-              </a:rPr>
-              <a:t>•   Aadhaar is masked in the admin preview and is never returned by the public API</a:t>
-            </a:r>
-          </a:p>
-        </p:txBody>
-      </p:sp>
-      <p:sp>
-        <p:nvSpPr>
-          <p:cNvPr id="6" name="TextBox 5"/>
-          <p:cNvSpPr txBox="1"/>
-          <p:nvPr/>
-        </p:nvSpPr>
-        <p:spPr>
-          <a:xfrm>
-            <a:off x="777240" y="6291072"/>
-            <a:ext cx="10637215" cy="320040"/>
-          </a:xfrm>
-          <a:prstGeom prst="rect">
-            <a:avLst/>
-          </a:prstGeom>
-          <a:noFill/>
-        </p:spPr>
-        <p:txBody>
-          <a:bodyPr wrap="square">
-            <a:spAutoFit/>
-          </a:bodyPr>
-          <a:lstStyle/>
-          <a:p>
-            <a:r>
-              <a:rPr sz="1000">
-                <a:solidFill>
-                  <a:srgbClr val="9CA3AF"/>
-                </a:solidFill>
-                <a:latin typeface="Calibri"/>
-              </a:rPr>
-              <a:t>Diya Meditation Kiosk  ·  Internship Report          5</a:t>
-            </a:r>
-          </a:p>
-        </p:txBody>
-      </p:sp>
+      </p:pic>
     </p:spTree>
   </p:cSld>
   <p:clrMapOvr>
@@ -6694,358 +5031,30 @@
         <p:nvPr/>
       </p:nvGrpSpPr>
       <p:grpSpPr/>
-      <p:sp>
-        <p:nvSpPr>
-          <p:cNvPr id="2" name="TextBox 1"/>
-          <p:cNvSpPr txBox="1"/>
+      <p:pic>
+        <p:nvPicPr>
+          <p:cNvPr id="2" name="Picture 1" descr="slide-06.png"/>
+          <p:cNvPicPr>
+            <a:picLocks noChangeAspect="1"/>
+          </p:cNvPicPr>
           <p:nvPr/>
-        </p:nvSpPr>
+        </p:nvPicPr>
+        <p:blipFill>
+          <a:blip r:embed="rId2"/>
+          <a:stretch>
+            <a:fillRect/>
+          </a:stretch>
+        </p:blipFill>
         <p:spPr>
           <a:xfrm>
-            <a:off x="777240" y="502920"/>
-            <a:ext cx="10637215" cy="274320"/>
+            <a:off x="0" y="0"/>
+            <a:ext cx="12191695" cy="6858000"/>
           </a:xfrm>
           <a:prstGeom prst="rect">
             <a:avLst/>
           </a:prstGeom>
-          <a:noFill/>
         </p:spPr>
-        <p:txBody>
-          <a:bodyPr wrap="square">
-            <a:spAutoFit/>
-          </a:bodyPr>
-          <a:lstStyle/>
-          <a:p>
-            <a:pPr algn="l">
-              <a:spcBef>
-                <a:spcPts val="0"/>
-              </a:spcBef>
-              <a:spcAft>
-                <a:spcPts val="0"/>
-              </a:spcAft>
-            </a:pPr>
-            <a:r>
-              <a:rPr sz="1100" b="1" i="0">
-                <a:solidFill>
-                  <a:srgbClr val="E9B872"/>
-                </a:solidFill>
-                <a:latin typeface="Calibri"/>
-              </a:rPr>
-              <a:t>ENGINEERING</a:t>
-            </a:r>
-          </a:p>
-        </p:txBody>
-      </p:sp>
-      <p:sp>
-        <p:nvSpPr>
-          <p:cNvPr id="3" name="TextBox 2"/>
-          <p:cNvSpPr txBox="1"/>
-          <p:nvPr/>
-        </p:nvSpPr>
-        <p:spPr>
-          <a:xfrm>
-            <a:off x="777240" y="777240"/>
-            <a:ext cx="10637215" cy="640080"/>
-          </a:xfrm>
-          <a:prstGeom prst="rect">
-            <a:avLst/>
-          </a:prstGeom>
-          <a:noFill/>
-        </p:spPr>
-        <p:txBody>
-          <a:bodyPr wrap="square">
-            <a:spAutoFit/>
-          </a:bodyPr>
-          <a:lstStyle/>
-          <a:p>
-            <a:pPr algn="l">
-              <a:spcBef>
-                <a:spcPts val="0"/>
-              </a:spcBef>
-              <a:spcAft>
-                <a:spcPts val="0"/>
-              </a:spcAft>
-            </a:pPr>
-            <a:r>
-              <a:rPr sz="3000" b="1" i="0">
-                <a:solidFill>
-                  <a:srgbClr val="1A1330"/>
-                </a:solidFill>
-                <a:latin typeface="Calibri"/>
-              </a:rPr>
-              <a:t>Problems That Took Real Debugging</a:t>
-            </a:r>
-          </a:p>
-        </p:txBody>
-      </p:sp>
-      <p:sp>
-        <p:nvSpPr>
-          <p:cNvPr id="4" name="Rectangle 3"/>
-          <p:cNvSpPr/>
-          <p:nvPr/>
-        </p:nvSpPr>
-        <p:spPr>
-          <a:xfrm>
-            <a:off x="777240" y="1481328"/>
-            <a:ext cx="1371600" cy="50800"/>
-          </a:xfrm>
-          <a:prstGeom prst="rect">
-            <a:avLst/>
-          </a:prstGeom>
-          <a:solidFill>
-            <a:srgbClr val="E9B872"/>
-          </a:solidFill>
-          <a:ln>
-            <a:noFill/>
-          </a:ln>
-          <a:effectLst/>
-        </p:spPr>
-        <p:style>
-          <a:lnRef idx="1">
-            <a:schemeClr val="accent1"/>
-          </a:lnRef>
-          <a:fillRef idx="3">
-            <a:schemeClr val="accent1"/>
-          </a:fillRef>
-          <a:effectRef idx="2">
-            <a:schemeClr val="accent1"/>
-          </a:effectRef>
-          <a:fontRef idx="minor">
-            <a:schemeClr val="lt1"/>
-          </a:fontRef>
-        </p:style>
-        <p:txBody>
-          <a:bodyPr rtlCol="0" anchor="ctr"/>
-          <a:lstStyle/>
-          <a:p>
-            <a:pPr algn="ctr"/>
-          </a:p>
-        </p:txBody>
-      </p:sp>
-      <p:sp>
-        <p:nvSpPr>
-          <p:cNvPr id="5" name="TextBox 4"/>
-          <p:cNvSpPr txBox="1"/>
-          <p:nvPr/>
-        </p:nvSpPr>
-        <p:spPr>
-          <a:xfrm>
-            <a:off x="777240" y="1783080"/>
-            <a:ext cx="10637215" cy="4389120"/>
-          </a:xfrm>
-          <a:prstGeom prst="rect">
-            <a:avLst/>
-          </a:prstGeom>
-          <a:noFill/>
-        </p:spPr>
-        <p:txBody>
-          <a:bodyPr wrap="square">
-            <a:spAutoFit/>
-          </a:bodyPr>
-          <a:lstStyle/>
-          <a:p>
-            <a:pPr algn="l">
-              <a:spcBef>
-                <a:spcPts val="0"/>
-              </a:spcBef>
-              <a:spcAft>
-                <a:spcPts val="400"/>
-              </a:spcAft>
-            </a:pPr>
-            <a:r>
-              <a:rPr sz="1500" b="1" i="0">
-                <a:solidFill>
-                  <a:srgbClr val="1A1330"/>
-                </a:solidFill>
-                <a:latin typeface="Calibri"/>
-              </a:rPr>
-              <a:t>Wayland / GNOME refused to make the window fullscreen</a:t>
-            </a:r>
-          </a:p>
-          <a:p>
-            <a:pPr algn="l">
-              <a:lnSpc>
-                <a:spcPct val="115000"/>
-              </a:lnSpc>
-              <a:spcBef>
-                <a:spcPts val="0"/>
-              </a:spcBef>
-              <a:spcAft>
-                <a:spcPts val="700"/>
-              </a:spcAft>
-            </a:pPr>
-            <a:r>
-              <a:rPr sz="1500" b="0" i="0">
-                <a:solidFill>
-                  <a:srgbClr val="374151"/>
-                </a:solidFill>
-                <a:latin typeface="Calibri"/>
-              </a:rPr>
-              <a:t>•   CanResize="False" sets fixed size hints, and the compositor then refuses the fullscreen request</a:t>
-            </a:r>
-          </a:p>
-          <a:p>
-            <a:pPr algn="l">
-              <a:lnSpc>
-                <a:spcPct val="115000"/>
-              </a:lnSpc>
-              <a:spcBef>
-                <a:spcPts val="0"/>
-              </a:spcBef>
-              <a:spcAft>
-                <a:spcPts val="700"/>
-              </a:spcAft>
-            </a:pPr>
-            <a:r>
-              <a:rPr sz="1500" b="0" i="0">
-                <a:solidFill>
-                  <a:srgbClr val="374151"/>
-                </a:solidFill>
-                <a:latin typeface="Calibri"/>
-              </a:rPr>
-              <a:t>•   Setting it in XAML doesn't stick either — it has to be applied in code and re-asserted on a timer</a:t>
-            </a:r>
-          </a:p>
-          <a:p>
-            <a:pPr algn="l">
-              <a:spcBef>
-                <a:spcPts val="1000"/>
-              </a:spcBef>
-              <a:spcAft>
-                <a:spcPts val="400"/>
-              </a:spcAft>
-            </a:pPr>
-            <a:r>
-              <a:rPr sz="1500" b="1" i="0">
-                <a:solidFill>
-                  <a:srgbClr val="1A1330"/>
-                </a:solidFill>
-                <a:latin typeface="Calibri"/>
-              </a:rPr>
-              <a:t>A dependency clash that would only have appeared at runtime</a:t>
-            </a:r>
-          </a:p>
-          <a:p>
-            <a:pPr algn="l">
-              <a:lnSpc>
-                <a:spcPct val="115000"/>
-              </a:lnSpc>
-              <a:spcBef>
-                <a:spcPts val="0"/>
-              </a:spcBef>
-              <a:spcAft>
-                <a:spcPts val="700"/>
-              </a:spcAft>
-            </a:pPr>
-            <a:r>
-              <a:rPr sz="1500" b="0" i="0">
-                <a:solidFill>
-                  <a:srgbClr val="374151"/>
-                </a:solidFill>
-                <a:latin typeface="Calibri"/>
-              </a:rPr>
-              <a:t>•   Avalonia and the PDF renderer both use SkiaSharp — I checked both resolved to the same version before committing to in-app rendering</a:t>
-            </a:r>
-          </a:p>
-          <a:p>
-            <a:pPr algn="l">
-              <a:spcBef>
-                <a:spcPts val="1000"/>
-              </a:spcBef>
-              <a:spcAft>
-                <a:spcPts val="400"/>
-              </a:spcAft>
-            </a:pPr>
-            <a:r>
-              <a:rPr sz="1500" b="1" i="0">
-                <a:solidFill>
-                  <a:srgbClr val="1A1330"/>
-                </a:solidFill>
-                <a:latin typeface="Calibri"/>
-              </a:rPr>
-              <a:t>“Couldn't connect to the server” — which was not the server</a:t>
-            </a:r>
-          </a:p>
-          <a:p>
-            <a:pPr algn="l">
-              <a:lnSpc>
-                <a:spcPct val="115000"/>
-              </a:lnSpc>
-              <a:spcBef>
-                <a:spcPts val="0"/>
-              </a:spcBef>
-              <a:spcAft>
-                <a:spcPts val="700"/>
-              </a:spcAft>
-            </a:pPr>
-            <a:r>
-              <a:rPr sz="1500" b="0" i="0">
-                <a:solidFill>
-                  <a:srgbClr val="374151"/>
-                </a:solidFill>
-                <a:latin typeface="Calibri"/>
-              </a:rPr>
-              <a:t>•   The test VM's clock was in the past, making valid HTTPS certificates look “not yet valid”</a:t>
-            </a:r>
-          </a:p>
-          <a:p>
-            <a:pPr algn="l">
-              <a:lnSpc>
-                <a:spcPct val="115000"/>
-              </a:lnSpc>
-              <a:spcBef>
-                <a:spcPts val="0"/>
-              </a:spcBef>
-              <a:spcAft>
-                <a:spcPts val="700"/>
-              </a:spcAft>
-            </a:pPr>
-            <a:r>
-              <a:rPr sz="1500" b="0" i="0">
-                <a:solidFill>
-                  <a:srgbClr val="374151"/>
-                </a:solidFill>
-                <a:latin typeface="Calibri"/>
-              </a:rPr>
-              <a:t>•   Fixed by clock sync, then written into the handoff doc so nobody loses that afternoon again</a:t>
-            </a:r>
-          </a:p>
-        </p:txBody>
-      </p:sp>
-      <p:sp>
-        <p:nvSpPr>
-          <p:cNvPr id="6" name="TextBox 5"/>
-          <p:cNvSpPr txBox="1"/>
-          <p:nvPr/>
-        </p:nvSpPr>
-        <p:spPr>
-          <a:xfrm>
-            <a:off x="777240" y="6291072"/>
-            <a:ext cx="10637215" cy="320040"/>
-          </a:xfrm>
-          <a:prstGeom prst="rect">
-            <a:avLst/>
-          </a:prstGeom>
-          <a:noFill/>
-        </p:spPr>
-        <p:txBody>
-          <a:bodyPr wrap="square">
-            <a:spAutoFit/>
-          </a:bodyPr>
-          <a:lstStyle/>
-          <a:p>
-            <a:r>
-              <a:rPr sz="1000">
-                <a:solidFill>
-                  <a:srgbClr val="9CA3AF"/>
-                </a:solidFill>
-                <a:latin typeface="Calibri"/>
-              </a:rPr>
-              <a:t>Diya Meditation Kiosk  ·  Internship Report          6</a:t>
-            </a:r>
-          </a:p>
-        </p:txBody>
-      </p:sp>
+      </p:pic>
     </p:spTree>
   </p:cSld>
   <p:clrMapOvr>
@@ -7064,380 +5073,30 @@
         <p:nvPr/>
       </p:nvGrpSpPr>
       <p:grpSpPr/>
-      <p:sp>
-        <p:nvSpPr>
-          <p:cNvPr id="2" name="TextBox 1"/>
-          <p:cNvSpPr txBox="1"/>
+      <p:pic>
+        <p:nvPicPr>
+          <p:cNvPr id="2" name="Picture 1" descr="slide-07.png"/>
+          <p:cNvPicPr>
+            <a:picLocks noChangeAspect="1"/>
+          </p:cNvPicPr>
           <p:nvPr/>
-        </p:nvSpPr>
+        </p:nvPicPr>
+        <p:blipFill>
+          <a:blip r:embed="rId2"/>
+          <a:stretch>
+            <a:fillRect/>
+          </a:stretch>
+        </p:blipFill>
         <p:spPr>
           <a:xfrm>
-            <a:off x="777240" y="502920"/>
-            <a:ext cx="10637215" cy="274320"/>
+            <a:off x="0" y="0"/>
+            <a:ext cx="12191695" cy="6858000"/>
           </a:xfrm>
           <a:prstGeom prst="rect">
             <a:avLst/>
           </a:prstGeom>
-          <a:noFill/>
         </p:spPr>
-        <p:txBody>
-          <a:bodyPr wrap="square">
-            <a:spAutoFit/>
-          </a:bodyPr>
-          <a:lstStyle/>
-          <a:p>
-            <a:pPr algn="l">
-              <a:spcBef>
-                <a:spcPts val="0"/>
-              </a:spcBef>
-              <a:spcAft>
-                <a:spcPts val="0"/>
-              </a:spcAft>
-            </a:pPr>
-            <a:r>
-              <a:rPr sz="1100" b="1" i="0">
-                <a:solidFill>
-                  <a:srgbClr val="E9B872"/>
-                </a:solidFill>
-                <a:latin typeface="Calibri"/>
-              </a:rPr>
-              <a:t>TESTING</a:t>
-            </a:r>
-          </a:p>
-        </p:txBody>
-      </p:sp>
-      <p:sp>
-        <p:nvSpPr>
-          <p:cNvPr id="3" name="TextBox 2"/>
-          <p:cNvSpPr txBox="1"/>
-          <p:nvPr/>
-        </p:nvSpPr>
-        <p:spPr>
-          <a:xfrm>
-            <a:off x="777240" y="777240"/>
-            <a:ext cx="10637215" cy="640080"/>
-          </a:xfrm>
-          <a:prstGeom prst="rect">
-            <a:avLst/>
-          </a:prstGeom>
-          <a:noFill/>
-        </p:spPr>
-        <p:txBody>
-          <a:bodyPr wrap="square">
-            <a:spAutoFit/>
-          </a:bodyPr>
-          <a:lstStyle/>
-          <a:p>
-            <a:pPr algn="l">
-              <a:spcBef>
-                <a:spcPts val="0"/>
-              </a:spcBef>
-              <a:spcAft>
-                <a:spcPts val="0"/>
-              </a:spcAft>
-            </a:pPr>
-            <a:r>
-              <a:rPr sz="3000" b="1" i="0">
-                <a:solidFill>
-                  <a:srgbClr val="1A1330"/>
-                </a:solidFill>
-                <a:latin typeface="Calibri"/>
-              </a:rPr>
-              <a:t>Building It Without the Hardware</a:t>
-            </a:r>
-          </a:p>
-        </p:txBody>
-      </p:sp>
-      <p:sp>
-        <p:nvSpPr>
-          <p:cNvPr id="4" name="Rectangle 3"/>
-          <p:cNvSpPr/>
-          <p:nvPr/>
-        </p:nvSpPr>
-        <p:spPr>
-          <a:xfrm>
-            <a:off x="777240" y="1481328"/>
-            <a:ext cx="1371600" cy="50800"/>
-          </a:xfrm>
-          <a:prstGeom prst="rect">
-            <a:avLst/>
-          </a:prstGeom>
-          <a:solidFill>
-            <a:srgbClr val="E9B872"/>
-          </a:solidFill>
-          <a:ln>
-            <a:noFill/>
-          </a:ln>
-          <a:effectLst/>
-        </p:spPr>
-        <p:style>
-          <a:lnRef idx="1">
-            <a:schemeClr val="accent1"/>
-          </a:lnRef>
-          <a:fillRef idx="3">
-            <a:schemeClr val="accent1"/>
-          </a:fillRef>
-          <a:effectRef idx="2">
-            <a:schemeClr val="accent1"/>
-          </a:effectRef>
-          <a:fontRef idx="minor">
-            <a:schemeClr val="lt1"/>
-          </a:fontRef>
-        </p:style>
-        <p:txBody>
-          <a:bodyPr rtlCol="0" anchor="ctr"/>
-          <a:lstStyle/>
-          <a:p>
-            <a:pPr algn="ctr"/>
-          </a:p>
-        </p:txBody>
-      </p:sp>
-      <p:sp>
-        <p:nvSpPr>
-          <p:cNvPr id="5" name="TextBox 4"/>
-          <p:cNvSpPr txBox="1"/>
-          <p:nvPr/>
-        </p:nvSpPr>
-        <p:spPr>
-          <a:xfrm>
-            <a:off x="777240" y="1783080"/>
-            <a:ext cx="10637215" cy="4389120"/>
-          </a:xfrm>
-          <a:prstGeom prst="rect">
-            <a:avLst/>
-          </a:prstGeom>
-          <a:noFill/>
-        </p:spPr>
-        <p:txBody>
-          <a:bodyPr wrap="square">
-            <a:spAutoFit/>
-          </a:bodyPr>
-          <a:lstStyle/>
-          <a:p>
-            <a:pPr algn="l">
-              <a:lnSpc>
-                <a:spcPct val="115000"/>
-              </a:lnSpc>
-              <a:spcBef>
-                <a:spcPts val="0"/>
-              </a:spcBef>
-              <a:spcAft>
-                <a:spcPts val="800"/>
-              </a:spcAft>
-            </a:pPr>
-            <a:r>
-              <a:rPr sz="1400" b="0" i="0">
-                <a:solidFill>
-                  <a:srgbClr val="374151"/>
-                </a:solidFill>
-                <a:latin typeface="Calibri"/>
-              </a:rPr>
-              <a:t>The real pipeline needs the cameras and the other team's app. For most of the internship I had neither — so the flow had to be testable without them.</a:t>
-            </a:r>
-          </a:p>
-          <a:p>
-            <a:pPr algn="l">
-              <a:spcBef>
-                <a:spcPts val="1000"/>
-              </a:spcBef>
-              <a:spcAft>
-                <a:spcPts val="400"/>
-              </a:spcAft>
-            </a:pPr>
-            <a:r>
-              <a:rPr sz="1500" b="1" i="0">
-                <a:solidFill>
-                  <a:srgbClr val="1A1330"/>
-                </a:solidFill>
-                <a:latin typeface="Calibri"/>
-              </a:rPr>
-              <a:t>A mock pipeline driven entirely by configuration</a:t>
-            </a:r>
-          </a:p>
-          <a:p>
-            <a:pPr algn="l">
-              <a:lnSpc>
-                <a:spcPct val="115000"/>
-              </a:lnSpc>
-              <a:spcBef>
-                <a:spcPts val="0"/>
-              </a:spcBef>
-              <a:spcAft>
-                <a:spcPts val="700"/>
-              </a:spcAft>
-            </a:pPr>
-            <a:r>
-              <a:rPr sz="1500" b="0" i="0">
-                <a:solidFill>
-                  <a:srgbClr val="374151"/>
-                </a:solidFill>
-                <a:latin typeface="Calibri"/>
-              </a:rPr>
-              <a:t>•   Two environment variables point the app at a stand-in script and a writable report folder</a:t>
-            </a:r>
-          </a:p>
-          <a:p>
-            <a:pPr algn="l">
-              <a:lnSpc>
-                <a:spcPct val="115000"/>
-              </a:lnSpc>
-              <a:spcBef>
-                <a:spcPts val="0"/>
-              </a:spcBef>
-              <a:spcAft>
-                <a:spcPts val="700"/>
-              </a:spcAft>
-            </a:pPr>
-            <a:r>
-              <a:rPr sz="1500" b="0" i="0">
-                <a:solidFill>
-                  <a:srgbClr val="374151"/>
-                </a:solidFill>
-                <a:latin typeface="Calibri"/>
-              </a:rPr>
-              <a:t>•   It prints status, waits, then drops a sample PDF — exercising login → session → report → thank-you</a:t>
-            </a:r>
-          </a:p>
-          <a:p>
-            <a:pPr algn="l">
-              <a:spcBef>
-                <a:spcPts val="1000"/>
-              </a:spcBef>
-              <a:spcAft>
-                <a:spcPts val="400"/>
-              </a:spcAft>
-            </a:pPr>
-            <a:r>
-              <a:rPr sz="1500" b="1" i="0">
-                <a:solidFill>
-                  <a:srgbClr val="1A1330"/>
-                </a:solidFill>
-                <a:latin typeface="Calibri"/>
-              </a:rPr>
-              <a:t>Why this way</a:t>
-            </a:r>
-          </a:p>
-          <a:p>
-            <a:pPr algn="l">
-              <a:lnSpc>
-                <a:spcPct val="115000"/>
-              </a:lnSpc>
-              <a:spcBef>
-                <a:spcPts val="0"/>
-              </a:spcBef>
-              <a:spcAft>
-                <a:spcPts val="700"/>
-              </a:spcAft>
-            </a:pPr>
-            <a:r>
-              <a:rPr sz="1500" b="0" i="0">
-                <a:solidFill>
-                  <a:srgbClr val="374151"/>
-                </a:solidFill>
-                <a:latin typeface="Calibri"/>
-              </a:rPr>
-              <a:t>•   No mock or test code inside the application, and nothing extra bundled into the shipped .deb</a:t>
-            </a:r>
-          </a:p>
-          <a:p>
-            <a:pPr algn="l">
-              <a:lnSpc>
-                <a:spcPct val="115000"/>
-              </a:lnSpc>
-              <a:spcBef>
-                <a:spcPts val="0"/>
-              </a:spcBef>
-              <a:spcAft>
-                <a:spcPts val="700"/>
-              </a:spcAft>
-            </a:pPr>
-            <a:r>
-              <a:rPr sz="1500" b="0" i="0">
-                <a:solidFill>
-                  <a:srgbClr val="374151"/>
-                </a:solidFill>
-                <a:latin typeface="Calibri"/>
-              </a:rPr>
-              <a:t>•   Those same variables are the real production override for both paths</a:t>
-            </a:r>
-          </a:p>
-          <a:p>
-            <a:pPr algn="l">
-              <a:spcBef>
-                <a:spcPts val="1000"/>
-              </a:spcBef>
-              <a:spcAft>
-                <a:spcPts val="400"/>
-              </a:spcAft>
-            </a:pPr>
-            <a:r>
-              <a:rPr sz="1500" b="1" i="0">
-                <a:solidFill>
-                  <a:srgbClr val="1A1330"/>
-                </a:solidFill>
-                <a:latin typeface="Calibri"/>
-              </a:rPr>
-              <a:t>A correctness bug this surfaced</a:t>
-            </a:r>
-          </a:p>
-          <a:p>
-            <a:pPr algn="l">
-              <a:lnSpc>
-                <a:spcPct val="115000"/>
-              </a:lnSpc>
-              <a:spcBef>
-                <a:spcPts val="0"/>
-              </a:spcBef>
-              <a:spcAft>
-                <a:spcPts val="700"/>
-              </a:spcAft>
-            </a:pPr>
-            <a:r>
-              <a:rPr sz="1500" b="0" i="0">
-                <a:solidFill>
-                  <a:srgbClr val="374151"/>
-                </a:solidFill>
-                <a:latin typeface="Calibri"/>
-              </a:rPr>
-              <a:t>•   The app only accepts a PDF written after the session began — so a previous visitor's report can never be shown to the wrong person</a:t>
-            </a:r>
-          </a:p>
-        </p:txBody>
-      </p:sp>
-      <p:sp>
-        <p:nvSpPr>
-          <p:cNvPr id="6" name="TextBox 5"/>
-          <p:cNvSpPr txBox="1"/>
-          <p:nvPr/>
-        </p:nvSpPr>
-        <p:spPr>
-          <a:xfrm>
-            <a:off x="777240" y="6291072"/>
-            <a:ext cx="10637215" cy="320040"/>
-          </a:xfrm>
-          <a:prstGeom prst="rect">
-            <a:avLst/>
-          </a:prstGeom>
-          <a:noFill/>
-        </p:spPr>
-        <p:txBody>
-          <a:bodyPr wrap="square">
-            <a:spAutoFit/>
-          </a:bodyPr>
-          <a:lstStyle/>
-          <a:p>
-            <a:r>
-              <a:rPr sz="1000">
-                <a:solidFill>
-                  <a:srgbClr val="9CA3AF"/>
-                </a:solidFill>
-                <a:latin typeface="Calibri"/>
-              </a:rPr>
-              <a:t>Diya Meditation Kiosk  ·  Internship Report          7</a:t>
-            </a:r>
-          </a:p>
-        </p:txBody>
-      </p:sp>
+      </p:pic>
     </p:spTree>
   </p:cSld>
   <p:clrMapOvr>
@@ -7456,377 +5115,30 @@
         <p:nvPr/>
       </p:nvGrpSpPr>
       <p:grpSpPr/>
-      <p:sp>
-        <p:nvSpPr>
-          <p:cNvPr id="2" name="TextBox 1"/>
-          <p:cNvSpPr txBox="1"/>
+      <p:pic>
+        <p:nvPicPr>
+          <p:cNvPr id="2" name="Picture 1" descr="slide-08.png"/>
+          <p:cNvPicPr>
+            <a:picLocks noChangeAspect="1"/>
+          </p:cNvPicPr>
           <p:nvPr/>
-        </p:nvSpPr>
+        </p:nvPicPr>
+        <p:blipFill>
+          <a:blip r:embed="rId2"/>
+          <a:stretch>
+            <a:fillRect/>
+          </a:stretch>
+        </p:blipFill>
         <p:spPr>
           <a:xfrm>
-            <a:off x="777240" y="502920"/>
-            <a:ext cx="10637215" cy="274320"/>
+            <a:off x="0" y="0"/>
+            <a:ext cx="12191695" cy="6858000"/>
           </a:xfrm>
           <a:prstGeom prst="rect">
             <a:avLst/>
           </a:prstGeom>
-          <a:noFill/>
         </p:spPr>
-        <p:txBody>
-          <a:bodyPr wrap="square">
-            <a:spAutoFit/>
-          </a:bodyPr>
-          <a:lstStyle/>
-          <a:p>
-            <a:pPr algn="l">
-              <a:spcBef>
-                <a:spcPts val="0"/>
-              </a:spcBef>
-              <a:spcAft>
-                <a:spcPts val="0"/>
-              </a:spcAft>
-            </a:pPr>
-            <a:r>
-              <a:rPr sz="1100" b="1" i="0">
-                <a:solidFill>
-                  <a:srgbClr val="E9B872"/>
-                </a:solidFill>
-                <a:latin typeface="Calibri"/>
-              </a:rPr>
-              <a:t>SHIPPING</a:t>
-            </a:r>
-          </a:p>
-        </p:txBody>
-      </p:sp>
-      <p:sp>
-        <p:nvSpPr>
-          <p:cNvPr id="3" name="TextBox 2"/>
-          <p:cNvSpPr txBox="1"/>
-          <p:nvPr/>
-        </p:nvSpPr>
-        <p:spPr>
-          <a:xfrm>
-            <a:off x="777240" y="777240"/>
-            <a:ext cx="10637215" cy="640080"/>
-          </a:xfrm>
-          <a:prstGeom prst="rect">
-            <a:avLst/>
-          </a:prstGeom>
-          <a:noFill/>
-        </p:spPr>
-        <p:txBody>
-          <a:bodyPr wrap="square">
-            <a:spAutoFit/>
-          </a:bodyPr>
-          <a:lstStyle/>
-          <a:p>
-            <a:pPr algn="l">
-              <a:spcBef>
-                <a:spcPts val="0"/>
-              </a:spcBef>
-              <a:spcAft>
-                <a:spcPts val="0"/>
-              </a:spcAft>
-            </a:pPr>
-            <a:r>
-              <a:rPr sz="3000" b="1" i="0">
-                <a:solidFill>
-                  <a:srgbClr val="1A1330"/>
-                </a:solidFill>
-                <a:latin typeface="Calibri"/>
-              </a:rPr>
-              <a:t>Packaging and Deployment</a:t>
-            </a:r>
-          </a:p>
-        </p:txBody>
-      </p:sp>
-      <p:sp>
-        <p:nvSpPr>
-          <p:cNvPr id="4" name="Rectangle 3"/>
-          <p:cNvSpPr/>
-          <p:nvPr/>
-        </p:nvSpPr>
-        <p:spPr>
-          <a:xfrm>
-            <a:off x="777240" y="1481328"/>
-            <a:ext cx="1371600" cy="50800"/>
-          </a:xfrm>
-          <a:prstGeom prst="rect">
-            <a:avLst/>
-          </a:prstGeom>
-          <a:solidFill>
-            <a:srgbClr val="E9B872"/>
-          </a:solidFill>
-          <a:ln>
-            <a:noFill/>
-          </a:ln>
-          <a:effectLst/>
-        </p:spPr>
-        <p:style>
-          <a:lnRef idx="1">
-            <a:schemeClr val="accent1"/>
-          </a:lnRef>
-          <a:fillRef idx="3">
-            <a:schemeClr val="accent1"/>
-          </a:fillRef>
-          <a:effectRef idx="2">
-            <a:schemeClr val="accent1"/>
-          </a:effectRef>
-          <a:fontRef idx="minor">
-            <a:schemeClr val="lt1"/>
-          </a:fontRef>
-        </p:style>
-        <p:txBody>
-          <a:bodyPr rtlCol="0" anchor="ctr"/>
-          <a:lstStyle/>
-          <a:p>
-            <a:pPr algn="ctr"/>
-          </a:p>
-        </p:txBody>
-      </p:sp>
-      <p:sp>
-        <p:nvSpPr>
-          <p:cNvPr id="5" name="TextBox 4"/>
-          <p:cNvSpPr txBox="1"/>
-          <p:nvPr/>
-        </p:nvSpPr>
-        <p:spPr>
-          <a:xfrm>
-            <a:off x="777240" y="1783080"/>
-            <a:ext cx="10637215" cy="4389120"/>
-          </a:xfrm>
-          <a:prstGeom prst="rect">
-            <a:avLst/>
-          </a:prstGeom>
-          <a:noFill/>
-        </p:spPr>
-        <p:txBody>
-          <a:bodyPr wrap="square">
-            <a:spAutoFit/>
-          </a:bodyPr>
-          <a:lstStyle/>
-          <a:p>
-            <a:pPr algn="l">
-              <a:spcBef>
-                <a:spcPts val="0"/>
-              </a:spcBef>
-              <a:spcAft>
-                <a:spcPts val="400"/>
-              </a:spcAft>
-            </a:pPr>
-            <a:r>
-              <a:rPr sz="1500" b="1" i="0">
-                <a:solidFill>
-                  <a:srgbClr val="1A1330"/>
-                </a:solidFill>
-                <a:latin typeface="Calibri"/>
-              </a:rPr>
-              <a:t>One command builds the package</a:t>
-            </a:r>
-          </a:p>
-          <a:p>
-            <a:pPr algn="l">
-              <a:lnSpc>
-                <a:spcPct val="115000"/>
-              </a:lnSpc>
-              <a:spcBef>
-                <a:spcPts val="0"/>
-              </a:spcBef>
-              <a:spcAft>
-                <a:spcPts val="700"/>
-              </a:spcAft>
-            </a:pPr>
-            <a:r>
-              <a:rPr sz="1500" b="0" i="0">
-                <a:solidFill>
-                  <a:srgbClr val="374151"/>
-                </a:solidFill>
-                <a:latin typeface="Calibri"/>
-              </a:rPr>
-              <a:t>•   Self-contained single-file .deb for amd64 or arm64; falls back from dpkg-deb to ar/tar so it builds on machines without Debian tooling</a:t>
-            </a:r>
-          </a:p>
-          <a:p>
-            <a:pPr algn="l">
-              <a:spcBef>
-                <a:spcPts val="1000"/>
-              </a:spcBef>
-              <a:spcAft>
-                <a:spcPts val="400"/>
-              </a:spcAft>
-            </a:pPr>
-            <a:r>
-              <a:rPr sz="1500" b="1" i="0">
-                <a:solidFill>
-                  <a:srgbClr val="1A1330"/>
-                </a:solidFill>
-                <a:latin typeface="Calibri"/>
-              </a:rPr>
-              <a:t>One script locks down the machine</a:t>
-            </a:r>
-          </a:p>
-          <a:p>
-            <a:pPr algn="l">
-              <a:lnSpc>
-                <a:spcPct val="115000"/>
-              </a:lnSpc>
-              <a:spcBef>
-                <a:spcPts val="0"/>
-              </a:spcBef>
-              <a:spcAft>
-                <a:spcPts val="700"/>
-              </a:spcAft>
-            </a:pPr>
-            <a:r>
-              <a:rPr sz="1500" b="0" i="0">
-                <a:solidFill>
-                  <a:srgbClr val="374151"/>
-                </a:solidFill>
-                <a:latin typeface="Calibri"/>
-              </a:rPr>
-              <a:t>•   Installs to /opt, registers a systemd user service with Restart=always so a crash can never leave the kiosk closed</a:t>
-            </a:r>
-          </a:p>
-          <a:p>
-            <a:pPr algn="l">
-              <a:lnSpc>
-                <a:spcPct val="115000"/>
-              </a:lnSpc>
-              <a:spcBef>
-                <a:spcPts val="0"/>
-              </a:spcBef>
-              <a:spcAft>
-                <a:spcPts val="700"/>
-              </a:spcAft>
-            </a:pPr>
-            <a:r>
-              <a:rPr sz="1500" b="0" i="0">
-                <a:solidFill>
-                  <a:srgbClr val="374151"/>
-                </a:solidFill>
-                <a:latin typeface="Calibri"/>
-              </a:rPr>
-              <a:t>•   Enables lingering and autologin so it comes up on boot, and disables the GNOME shortcuts a visitor could use to escape the app</a:t>
-            </a:r>
-          </a:p>
-          <a:p>
-            <a:pPr algn="l">
-              <a:spcBef>
-                <a:spcPts val="1000"/>
-              </a:spcBef>
-              <a:spcAft>
-                <a:spcPts val="400"/>
-              </a:spcAft>
-            </a:pPr>
-            <a:r>
-              <a:rPr sz="1500" b="1" i="0">
-                <a:solidFill>
-                  <a:srgbClr val="1A1330"/>
-                </a:solidFill>
-                <a:latin typeface="Calibri"/>
-              </a:rPr>
-              <a:t>One blueprint deploys the backend</a:t>
-            </a:r>
-          </a:p>
-          <a:p>
-            <a:pPr algn="l">
-              <a:lnSpc>
-                <a:spcPct val="115000"/>
-              </a:lnSpc>
-              <a:spcBef>
-                <a:spcPts val="0"/>
-              </a:spcBef>
-              <a:spcAft>
-                <a:spcPts val="700"/>
-              </a:spcAft>
-            </a:pPr>
-            <a:r>
-              <a:rPr sz="1500" b="0" i="0">
-                <a:solidFill>
-                  <a:srgbClr val="374151"/>
-                </a:solidFill>
-                <a:latin typeface="Calibri"/>
-              </a:rPr>
-              <a:t>•   render.yaml provisions the web service and Postgres together</a:t>
-            </a:r>
-          </a:p>
-          <a:p>
-            <a:pPr algn="l">
-              <a:spcBef>
-                <a:spcPts val="1000"/>
-              </a:spcBef>
-              <a:spcAft>
-                <a:spcPts val="400"/>
-              </a:spcAft>
-            </a:pPr>
-            <a:r>
-              <a:rPr sz="1500" b="1" i="0">
-                <a:solidFill>
-                  <a:srgbClr val="1A1330"/>
-                </a:solidFill>
-                <a:latin typeface="Calibri"/>
-              </a:rPr>
-              <a:t>Documentation written for the next person, not for me</a:t>
-            </a:r>
-          </a:p>
-          <a:p>
-            <a:pPr algn="l">
-              <a:lnSpc>
-                <a:spcPct val="115000"/>
-              </a:lnSpc>
-              <a:spcBef>
-                <a:spcPts val="0"/>
-              </a:spcBef>
-              <a:spcAft>
-                <a:spcPts val="700"/>
-              </a:spcAft>
-            </a:pPr>
-            <a:r>
-              <a:rPr sz="1500" b="0" i="0">
-                <a:solidFill>
-                  <a:srgbClr val="374151"/>
-                </a:solidFill>
-                <a:latin typeface="Calibri"/>
-              </a:rPr>
-              <a:t>•   Overview, full command reference, an FAQ, a file-by-file PDF, and a handoff doc with the gotchas and dead ends</a:t>
-            </a:r>
-          </a:p>
-        </p:txBody>
-      </p:sp>
-      <p:sp>
-        <p:nvSpPr>
-          <p:cNvPr id="6" name="TextBox 5"/>
-          <p:cNvSpPr txBox="1"/>
-          <p:nvPr/>
-        </p:nvSpPr>
-        <p:spPr>
-          <a:xfrm>
-            <a:off x="777240" y="6291072"/>
-            <a:ext cx="10637215" cy="320040"/>
-          </a:xfrm>
-          <a:prstGeom prst="rect">
-            <a:avLst/>
-          </a:prstGeom>
-          <a:noFill/>
-        </p:spPr>
-        <p:txBody>
-          <a:bodyPr wrap="square">
-            <a:spAutoFit/>
-          </a:bodyPr>
-          <a:lstStyle/>
-          <a:p>
-            <a:r>
-              <a:rPr sz="1000">
-                <a:solidFill>
-                  <a:srgbClr val="9CA3AF"/>
-                </a:solidFill>
-                <a:latin typeface="Calibri"/>
-              </a:rPr>
-              <a:t>Diya Meditation Kiosk  ·  Internship Report          8</a:t>
-            </a:r>
-          </a:p>
-        </p:txBody>
-      </p:sp>
+      </p:pic>
     </p:spTree>
   </p:cSld>
   <p:clrMapOvr>
@@ -7845,383 +5157,30 @@
         <p:nvPr/>
       </p:nvGrpSpPr>
       <p:grpSpPr/>
-      <p:sp>
-        <p:nvSpPr>
-          <p:cNvPr id="2" name="TextBox 1"/>
-          <p:cNvSpPr txBox="1"/>
+      <p:pic>
+        <p:nvPicPr>
+          <p:cNvPr id="2" name="Picture 1" descr="slide-09.png"/>
+          <p:cNvPicPr>
+            <a:picLocks noChangeAspect="1"/>
+          </p:cNvPicPr>
           <p:nvPr/>
-        </p:nvSpPr>
+        </p:nvPicPr>
+        <p:blipFill>
+          <a:blip r:embed="rId2"/>
+          <a:stretch>
+            <a:fillRect/>
+          </a:stretch>
+        </p:blipFill>
         <p:spPr>
           <a:xfrm>
-            <a:off x="777240" y="502920"/>
-            <a:ext cx="10637215" cy="274320"/>
+            <a:off x="0" y="0"/>
+            <a:ext cx="12191695" cy="6858000"/>
           </a:xfrm>
           <a:prstGeom prst="rect">
             <a:avLst/>
           </a:prstGeom>
-          <a:noFill/>
         </p:spPr>
-        <p:txBody>
-          <a:bodyPr wrap="square">
-            <a:spAutoFit/>
-          </a:bodyPr>
-          <a:lstStyle/>
-          <a:p>
-            <a:pPr algn="l">
-              <a:spcBef>
-                <a:spcPts val="0"/>
-              </a:spcBef>
-              <a:spcAft>
-                <a:spcPts val="0"/>
-              </a:spcAft>
-            </a:pPr>
-            <a:r>
-              <a:rPr sz="1100" b="1" i="0">
-                <a:solidFill>
-                  <a:srgbClr val="E9B872"/>
-                </a:solidFill>
-                <a:latin typeface="Calibri"/>
-              </a:rPr>
-              <a:t>CURRENT STATE</a:t>
-            </a:r>
-          </a:p>
-        </p:txBody>
-      </p:sp>
-      <p:sp>
-        <p:nvSpPr>
-          <p:cNvPr id="3" name="TextBox 2"/>
-          <p:cNvSpPr txBox="1"/>
-          <p:nvPr/>
-        </p:nvSpPr>
-        <p:spPr>
-          <a:xfrm>
-            <a:off x="777240" y="777240"/>
-            <a:ext cx="10637215" cy="640080"/>
-          </a:xfrm>
-          <a:prstGeom prst="rect">
-            <a:avLst/>
-          </a:prstGeom>
-          <a:noFill/>
-        </p:spPr>
-        <p:txBody>
-          <a:bodyPr wrap="square">
-            <a:spAutoFit/>
-          </a:bodyPr>
-          <a:lstStyle/>
-          <a:p>
-            <a:pPr algn="l">
-              <a:spcBef>
-                <a:spcPts val="0"/>
-              </a:spcBef>
-              <a:spcAft>
-                <a:spcPts val="0"/>
-              </a:spcAft>
-            </a:pPr>
-            <a:r>
-              <a:rPr sz="3000" b="1" i="0">
-                <a:solidFill>
-                  <a:srgbClr val="1A1330"/>
-                </a:solidFill>
-                <a:latin typeface="Calibri"/>
-              </a:rPr>
-              <a:t>Where I Left It, Honestly</a:t>
-            </a:r>
-          </a:p>
-        </p:txBody>
-      </p:sp>
-      <p:sp>
-        <p:nvSpPr>
-          <p:cNvPr id="4" name="Rectangle 3"/>
-          <p:cNvSpPr/>
-          <p:nvPr/>
-        </p:nvSpPr>
-        <p:spPr>
-          <a:xfrm>
-            <a:off x="777240" y="1481328"/>
-            <a:ext cx="1371600" cy="50800"/>
-          </a:xfrm>
-          <a:prstGeom prst="rect">
-            <a:avLst/>
-          </a:prstGeom>
-          <a:solidFill>
-            <a:srgbClr val="E9B872"/>
-          </a:solidFill>
-          <a:ln>
-            <a:noFill/>
-          </a:ln>
-          <a:effectLst/>
-        </p:spPr>
-        <p:style>
-          <a:lnRef idx="1">
-            <a:schemeClr val="accent1"/>
-          </a:lnRef>
-          <a:fillRef idx="3">
-            <a:schemeClr val="accent1"/>
-          </a:fillRef>
-          <a:effectRef idx="2">
-            <a:schemeClr val="accent1"/>
-          </a:effectRef>
-          <a:fontRef idx="minor">
-            <a:schemeClr val="lt1"/>
-          </a:fontRef>
-        </p:style>
-        <p:txBody>
-          <a:bodyPr rtlCol="0" anchor="ctr"/>
-          <a:lstStyle/>
-          <a:p>
-            <a:pPr algn="ctr"/>
-          </a:p>
-        </p:txBody>
-      </p:sp>
-      <p:sp>
-        <p:nvSpPr>
-          <p:cNvPr id="5" name="TextBox 4"/>
-          <p:cNvSpPr txBox="1"/>
-          <p:nvPr/>
-        </p:nvSpPr>
-        <p:spPr>
-          <a:xfrm>
-            <a:off x="777240" y="1783080"/>
-            <a:ext cx="10637215" cy="4389120"/>
-          </a:xfrm>
-          <a:prstGeom prst="rect">
-            <a:avLst/>
-          </a:prstGeom>
-          <a:noFill/>
-        </p:spPr>
-        <p:txBody>
-          <a:bodyPr wrap="square">
-            <a:spAutoFit/>
-          </a:bodyPr>
-          <a:lstStyle/>
-          <a:p>
-            <a:pPr algn="l">
-              <a:spcBef>
-                <a:spcPts val="0"/>
-              </a:spcBef>
-              <a:spcAft>
-                <a:spcPts val="400"/>
-              </a:spcAft>
-            </a:pPr>
-            <a:r>
-              <a:rPr sz="1500" b="1" i="0">
-                <a:solidFill>
-                  <a:srgbClr val="1A1330"/>
-                </a:solidFill>
-                <a:latin typeface="Calibri"/>
-              </a:rPr>
-              <a:t>Working end to end</a:t>
-            </a:r>
-          </a:p>
-          <a:p>
-            <a:pPr algn="l">
-              <a:lnSpc>
-                <a:spcPct val="115000"/>
-              </a:lnSpc>
-              <a:spcBef>
-                <a:spcPts val="0"/>
-              </a:spcBef>
-              <a:spcAft>
-                <a:spcPts val="700"/>
-              </a:spcAft>
-            </a:pPr>
-            <a:r>
-              <a:rPr sz="1500" b="0" i="0">
-                <a:solidFill>
-                  <a:srgbClr val="374151"/>
-                </a:solidFill>
-                <a:latin typeface="Calibri"/>
-              </a:rPr>
-              <a:t>•   Roster upload → phone login → session claim → automatic pipeline launch → report rendered in-app → reset for the next visitor</a:t>
-            </a:r>
-          </a:p>
-          <a:p>
-            <a:pPr algn="l">
-              <a:lnSpc>
-                <a:spcPct val="115000"/>
-              </a:lnSpc>
-              <a:spcBef>
-                <a:spcPts val="0"/>
-              </a:spcBef>
-              <a:spcAft>
-                <a:spcPts val="700"/>
-              </a:spcAft>
-            </a:pPr>
-            <a:r>
-              <a:rPr sz="1500" b="0" i="0">
-                <a:solidFill>
-                  <a:srgbClr val="374151"/>
-                </a:solidFill>
-                <a:latin typeface="Calibri"/>
-              </a:rPr>
-              <a:t>•   Packaged and installable for both architectures, with the backend deployed and live</a:t>
-            </a:r>
-          </a:p>
-          <a:p>
-            <a:pPr algn="l">
-              <a:spcBef>
-                <a:spcPts val="1000"/>
-              </a:spcBef>
-              <a:spcAft>
-                <a:spcPts val="400"/>
-              </a:spcAft>
-            </a:pPr>
-            <a:r>
-              <a:rPr sz="1500" b="1" i="0">
-                <a:solidFill>
-                  <a:srgbClr val="1A1330"/>
-                </a:solidFill>
-                <a:latin typeface="Calibri"/>
-              </a:rPr>
-              <a:t>Known limitations — all documented for whoever picks this up</a:t>
-            </a:r>
-          </a:p>
-          <a:p>
-            <a:pPr algn="l">
-              <a:lnSpc>
-                <a:spcPct val="115000"/>
-              </a:lnSpc>
-              <a:spcBef>
-                <a:spcPts val="0"/>
-              </a:spcBef>
-              <a:spcAft>
-                <a:spcPts val="700"/>
-              </a:spcAft>
-            </a:pPr>
-            <a:r>
-              <a:rPr sz="1500" b="0" i="0">
-                <a:solidFill>
-                  <a:srgbClr val="374151"/>
-                </a:solidFill>
-                <a:latin typeface="Calibri"/>
-              </a:rPr>
-              <a:t>•   The visitor's identity is not yet passed into the pipeline, so the report is not personalised</a:t>
-            </a:r>
-          </a:p>
-          <a:p>
-            <a:pPr algn="l">
-              <a:lnSpc>
-                <a:spcPct val="115000"/>
-              </a:lnSpc>
-              <a:spcBef>
-                <a:spcPts val="0"/>
-              </a:spcBef>
-              <a:spcAft>
-                <a:spcPts val="700"/>
-              </a:spcAft>
-            </a:pPr>
-            <a:r>
-              <a:rPr sz="1500" b="0" i="0">
-                <a:solidFill>
-                  <a:srgbClr val="374151"/>
-                </a:solidFill>
-                <a:latin typeface="Calibri"/>
-              </a:rPr>
-              <a:t>•   The pipeline script retries indefinitely with no timeout — it needs a ceiling and a failure screen</a:t>
-            </a:r>
-          </a:p>
-          <a:p>
-            <a:pPr algn="l">
-              <a:lnSpc>
-                <a:spcPct val="115000"/>
-              </a:lnSpc>
-              <a:spcBef>
-                <a:spcPts val="0"/>
-              </a:spcBef>
-              <a:spcAft>
-                <a:spcPts val="700"/>
-              </a:spcAft>
-            </a:pPr>
-            <a:r>
-              <a:rPr sz="1500" b="0" i="0">
-                <a:solidFill>
-                  <a:srgbClr val="374151"/>
-                </a:solidFill>
-                <a:latin typeface="Calibri"/>
-              </a:rPr>
-              <a:t>•   No consent screen, which a kiosk using cameras and storing ID numbers should have</a:t>
-            </a:r>
-          </a:p>
-          <a:p>
-            <a:pPr algn="l">
-              <a:lnSpc>
-                <a:spcPct val="115000"/>
-              </a:lnSpc>
-              <a:spcBef>
-                <a:spcPts val="0"/>
-              </a:spcBef>
-              <a:spcAft>
-                <a:spcPts val="700"/>
-              </a:spcAft>
-            </a:pPr>
-            <a:r>
-              <a:rPr sz="1500" b="0" i="0">
-                <a:solidFill>
-                  <a:srgbClr val="374151"/>
-                </a:solidFill>
-                <a:latin typeface="Calibri"/>
-              </a:rPr>
-              <a:t>•   Real camera hardware is not yet integrated — the interface is ready, the devices were not</a:t>
-            </a:r>
-          </a:p>
-          <a:p>
-            <a:pPr algn="l">
-              <a:lnSpc>
-                <a:spcPct val="115000"/>
-              </a:lnSpc>
-              <a:spcBef>
-                <a:spcPts val="0"/>
-              </a:spcBef>
-              <a:spcAft>
-                <a:spcPts val="700"/>
-              </a:spcAft>
-            </a:pPr>
-            <a:r>
-              <a:rPr sz="1500" b="0" i="0">
-                <a:solidFill>
-                  <a:srgbClr val="374151"/>
-                </a:solidFill>
-                <a:latin typeface="Calibri"/>
-              </a:rPr>
-              <a:t>•   Prebuilt packages live in the repository; these belong in an automated build and releases</a:t>
-            </a:r>
-          </a:p>
-        </p:txBody>
-      </p:sp>
-      <p:sp>
-        <p:nvSpPr>
-          <p:cNvPr id="6" name="TextBox 5"/>
-          <p:cNvSpPr txBox="1"/>
-          <p:nvPr/>
-        </p:nvSpPr>
-        <p:spPr>
-          <a:xfrm>
-            <a:off x="777240" y="6291072"/>
-            <a:ext cx="10637215" cy="320040"/>
-          </a:xfrm>
-          <a:prstGeom prst="rect">
-            <a:avLst/>
-          </a:prstGeom>
-          <a:noFill/>
-        </p:spPr>
-        <p:txBody>
-          <a:bodyPr wrap="square">
-            <a:spAutoFit/>
-          </a:bodyPr>
-          <a:lstStyle/>
-          <a:p>
-            <a:r>
-              <a:rPr sz="1000">
-                <a:solidFill>
-                  <a:srgbClr val="9CA3AF"/>
-                </a:solidFill>
-                <a:latin typeface="Calibri"/>
-              </a:rPr>
-              <a:t>Diya Meditation Kiosk  ·  Internship Report          9</a:t>
-            </a:r>
-          </a:p>
-        </p:txBody>
-      </p:sp>
+      </p:pic>
     </p:spTree>
   </p:cSld>
   <p:clrMapOvr>

</xml_diff>